<commit_message>
Finalize deck, guides and verified offline kit
</commit_message>
<xml_diff>
--- a/downloads/workshop-slides.pptx
+++ b/downloads/workshop-slides.pptx
@@ -2,26 +2,26 @@
 <file path=ppt/presentation.xml><?xml version="1.0" encoding="utf-8"?>
 <p:presentation xmlns:p="http://schemas.openxmlformats.org/presentationml/2006/main">
   <p:sldMasterIdLst>
-    <p:sldMasterId xmlns:r="http://schemas.openxmlformats.org/officeDocument/2006/relationships" id="2147483648" r:id="R4de1ee7776ea4111"/>
+    <p:sldMasterId xmlns:r="http://schemas.openxmlformats.org/officeDocument/2006/relationships" id="2147483648" r:id="Re394ba3f49694d1e"/>
   </p:sldMasterIdLst>
   <p:notesMasterIdLst>
-    <p:notesMasterId xmlns:r="http://schemas.openxmlformats.org/officeDocument/2006/relationships" r:id="Rf43c57e796af4e6c"/>
+    <p:notesMasterId xmlns:r="http://schemas.openxmlformats.org/officeDocument/2006/relationships" r:id="R7bbd98e2ad65429e"/>
   </p:notesMasterIdLst>
   <p:sldIdLst>
-    <p:sldId xmlns:r="http://schemas.openxmlformats.org/officeDocument/2006/relationships" id="256" r:id="R7a842f582cd54bf1"/>
-    <p:sldId xmlns:r="http://schemas.openxmlformats.org/officeDocument/2006/relationships" id="257" r:id="Reae82352cb194793"/>
-    <p:sldId xmlns:r="http://schemas.openxmlformats.org/officeDocument/2006/relationships" id="258" r:id="R3639eba3c37944a3"/>
-    <p:sldId xmlns:r="http://schemas.openxmlformats.org/officeDocument/2006/relationships" id="259" r:id="R6f89991bba9e48eb"/>
-    <p:sldId xmlns:r="http://schemas.openxmlformats.org/officeDocument/2006/relationships" id="260" r:id="R4aaf5e6750a84d1a"/>
-    <p:sldId xmlns:r="http://schemas.openxmlformats.org/officeDocument/2006/relationships" id="261" r:id="Rf8efb75516774c11"/>
-    <p:sldId xmlns:r="http://schemas.openxmlformats.org/officeDocument/2006/relationships" id="262" r:id="Rdf25d81774144a43"/>
-    <p:sldId xmlns:r="http://schemas.openxmlformats.org/officeDocument/2006/relationships" id="263" r:id="R2e49da8771434e4d"/>
-    <p:sldId xmlns:r="http://schemas.openxmlformats.org/officeDocument/2006/relationships" id="264" r:id="R2c718b814bb14cec"/>
-    <p:sldId xmlns:r="http://schemas.openxmlformats.org/officeDocument/2006/relationships" id="265" r:id="Rfd88fe5ab8b54e5c"/>
-    <p:sldId xmlns:r="http://schemas.openxmlformats.org/officeDocument/2006/relationships" id="266" r:id="Rfec001fb63a74fa0"/>
-    <p:sldId xmlns:r="http://schemas.openxmlformats.org/officeDocument/2006/relationships" id="267" r:id="Rc7db78ede76642fd"/>
-    <p:sldId xmlns:r="http://schemas.openxmlformats.org/officeDocument/2006/relationships" id="268" r:id="Rad2caaf15bd4444f"/>
-    <p:sldId xmlns:r="http://schemas.openxmlformats.org/officeDocument/2006/relationships" id="269" r:id="R19a39585595b4af2"/>
+    <p:sldId xmlns:r="http://schemas.openxmlformats.org/officeDocument/2006/relationships" id="256" r:id="R120e24263cb048fc"/>
+    <p:sldId xmlns:r="http://schemas.openxmlformats.org/officeDocument/2006/relationships" id="257" r:id="R5a72becd45d54540"/>
+    <p:sldId xmlns:r="http://schemas.openxmlformats.org/officeDocument/2006/relationships" id="258" r:id="Rc4342b303614416f"/>
+    <p:sldId xmlns:r="http://schemas.openxmlformats.org/officeDocument/2006/relationships" id="259" r:id="R91fc96cadc8f4b5f"/>
+    <p:sldId xmlns:r="http://schemas.openxmlformats.org/officeDocument/2006/relationships" id="260" r:id="R86d3d1cb4b314723"/>
+    <p:sldId xmlns:r="http://schemas.openxmlformats.org/officeDocument/2006/relationships" id="261" r:id="Rb22ee8a12c40447b"/>
+    <p:sldId xmlns:r="http://schemas.openxmlformats.org/officeDocument/2006/relationships" id="262" r:id="R2a30ada21b474d92"/>
+    <p:sldId xmlns:r="http://schemas.openxmlformats.org/officeDocument/2006/relationships" id="263" r:id="R13b52127ac3a4483"/>
+    <p:sldId xmlns:r="http://schemas.openxmlformats.org/officeDocument/2006/relationships" id="264" r:id="R96795fea57674b75"/>
+    <p:sldId xmlns:r="http://schemas.openxmlformats.org/officeDocument/2006/relationships" id="265" r:id="Rcca9976c85564c98"/>
+    <p:sldId xmlns:r="http://schemas.openxmlformats.org/officeDocument/2006/relationships" id="266" r:id="Re84f0f60dced44a0"/>
+    <p:sldId xmlns:r="http://schemas.openxmlformats.org/officeDocument/2006/relationships" id="267" r:id="R6e40f12444624d32"/>
+    <p:sldId xmlns:r="http://schemas.openxmlformats.org/officeDocument/2006/relationships" id="268" r:id="Rd5eb9072492f46e7"/>
+    <p:sldId xmlns:r="http://schemas.openxmlformats.org/officeDocument/2006/relationships" id="269" r:id="Rab8b0174d9944b2a"/>
   </p:sldIdLst>
   <p:sldSz cx="12192000" cy="6858000"/>
   <p:notesSz cx="6858000" cy="9144000"/>
@@ -455,7 +455,7 @@
           <a:lstStyle xmlns:a="http://schemas.openxmlformats.org/drawingml/2006/main"/>
           <a:p xmlns:a="http://schemas.openxmlformats.org/drawingml/2006/main">
             <a:r>
-              <a:t>0:00–1:00. Welcome. I'm Junead, a UNC alum and Treasury founder. Money interfaces make you care about which number matters, the date attached to it, and the next action. Today we give AI those choices explicitly. This workshop uses fictional data and a prepared starter. It is not a product demo or a model benchmark.</a:t>
+              <a:t>0:00–1:00. Welcome. I'm Junead, the founder of Treasury. Money interfaces make you care about which number matters, the date attached to it, and the next action. Today we give AI those choices explicitly. This workshop uses fictional data and a prepared starter. It is not a product demo or a model benchmark.</a:t>
             </a:r>
           </a:p>
           <a:p xmlns:a="http://schemas.openxmlformats.org/drawingml/2006/main">
@@ -1477,7 +1477,7 @@
           <p:cNvPr id="3" name="Title">
             <a:extLst xmlns:a="http://schemas.openxmlformats.org/drawingml/2006/main">
               <a:ext uri="{FF2B5EF4-FFF2-40B4-BE49-F238E27FC236}">
-                <a16:creationId xmlns:a16="http://schemas.microsoft.com/office/drawing/2014/main" id="{74F89E83-2B4E-4CC0-80F8-AB2938ADAA6D}"/>
+                <a16:creationId xmlns:a16="http://schemas.microsoft.com/office/drawing/2014/main" id="{467FD364-8F8E-46E7-9872-5C7A78E75390}"/>
               </a:ext>
             </a:extLst>
           </p:cNvPr>
@@ -1634,7 +1634,7 @@
           <p:cNvPr id="2" name="Subtitle">
             <a:extLst xmlns:a="http://schemas.openxmlformats.org/drawingml/2006/main">
               <a:ext uri="{FF2B5EF4-FFF2-40B4-BE49-F238E27FC236}">
-                <a16:creationId xmlns:a16="http://schemas.microsoft.com/office/drawing/2014/main" id="{FECA2522-5F11-4E5E-BD5C-7BED4C1F9B5B}"/>
+                <a16:creationId xmlns:a16="http://schemas.microsoft.com/office/drawing/2014/main" id="{D7C13CCE-2392-431B-A27D-D81231D845A6}"/>
               </a:ext>
             </a:extLst>
           </p:cNvPr>
@@ -1808,7 +1808,7 @@
           <p:cNvPr id="2" name="Section title">
             <a:extLst xmlns:a="http://schemas.openxmlformats.org/drawingml/2006/main">
               <a:ext uri="{FF2B5EF4-FFF2-40B4-BE49-F238E27FC236}">
-                <a16:creationId xmlns:a16="http://schemas.microsoft.com/office/drawing/2014/main" id="{CAB86F99-5D5A-4F97-AA2D-8393B4DA0445}"/>
+                <a16:creationId xmlns:a16="http://schemas.microsoft.com/office/drawing/2014/main" id="{8CF4D683-4ED2-4866-96E6-1F092F46CEEB}"/>
               </a:ext>
             </a:extLst>
           </p:cNvPr>
@@ -1982,7 +1982,7 @@
           <p:cNvPr id="3" name="Title">
             <a:extLst xmlns:a="http://schemas.openxmlformats.org/drawingml/2006/main">
               <a:ext uri="{FF2B5EF4-FFF2-40B4-BE49-F238E27FC236}">
-                <a16:creationId xmlns:a16="http://schemas.microsoft.com/office/drawing/2014/main" id="{6D69A4AC-3569-48AF-A294-9DC383C33768}"/>
+                <a16:creationId xmlns:a16="http://schemas.microsoft.com/office/drawing/2014/main" id="{1442A1D8-4609-4309-99E8-2421FE7AA607}"/>
               </a:ext>
             </a:extLst>
           </p:cNvPr>
@@ -2139,7 +2139,7 @@
           <p:cNvPr id="2" name="Body">
             <a:extLst xmlns:a="http://schemas.openxmlformats.org/drawingml/2006/main">
               <a:ext uri="{FF2B5EF4-FFF2-40B4-BE49-F238E27FC236}">
-                <a16:creationId xmlns:a16="http://schemas.microsoft.com/office/drawing/2014/main" id="{5F29CE7B-DB89-49D3-961F-3B0B5E9ABA52}"/>
+                <a16:creationId xmlns:a16="http://schemas.microsoft.com/office/drawing/2014/main" id="{F9675B36-CD39-4682-8AA3-9EA65286995B}"/>
               </a:ext>
             </a:extLst>
           </p:cNvPr>
@@ -2313,7 +2313,7 @@
           <p:cNvPr id="4" name="Title">
             <a:extLst xmlns:a="http://schemas.openxmlformats.org/drawingml/2006/main">
               <a:ext uri="{FF2B5EF4-FFF2-40B4-BE49-F238E27FC236}">
-                <a16:creationId xmlns:a16="http://schemas.microsoft.com/office/drawing/2014/main" id="{E1ED0FCB-694F-48C8-ADF4-BE8BFCC252AD}"/>
+                <a16:creationId xmlns:a16="http://schemas.microsoft.com/office/drawing/2014/main" id="{371DF262-E759-40BF-90D4-8F2A47F5F354}"/>
               </a:ext>
             </a:extLst>
           </p:cNvPr>
@@ -2470,7 +2470,7 @@
           <p:cNvPr id="2" name="Left column">
             <a:extLst xmlns:a="http://schemas.openxmlformats.org/drawingml/2006/main">
               <a:ext uri="{FF2B5EF4-FFF2-40B4-BE49-F238E27FC236}">
-                <a16:creationId xmlns:a16="http://schemas.microsoft.com/office/drawing/2014/main" id="{D3C0FC3D-CFBB-49E9-A234-ED364814BD54}"/>
+                <a16:creationId xmlns:a16="http://schemas.microsoft.com/office/drawing/2014/main" id="{7642D221-D635-4E50-A2C1-AEDEB0C91ED0}"/>
               </a:ext>
             </a:extLst>
           </p:cNvPr>
@@ -2627,7 +2627,7 @@
           <p:cNvPr id="3" name="Right column">
             <a:extLst xmlns:a="http://schemas.openxmlformats.org/drawingml/2006/main">
               <a:ext uri="{FF2B5EF4-FFF2-40B4-BE49-F238E27FC236}">
-                <a16:creationId xmlns:a16="http://schemas.microsoft.com/office/drawing/2014/main" id="{02843A9B-0A9D-4052-AD32-8243442E257D}"/>
+                <a16:creationId xmlns:a16="http://schemas.microsoft.com/office/drawing/2014/main" id="{0204015C-BB1C-483C-9E00-F43467EB2CB9}"/>
               </a:ext>
             </a:extLst>
           </p:cNvPr>
@@ -2801,7 +2801,7 @@
           <p:cNvPr id="3" name="Title">
             <a:extLst xmlns:a="http://schemas.openxmlformats.org/drawingml/2006/main">
               <a:ext uri="{FF2B5EF4-FFF2-40B4-BE49-F238E27FC236}">
-                <a16:creationId xmlns:a16="http://schemas.microsoft.com/office/drawing/2014/main" id="{84D964B9-5D23-47BA-B4B3-F0F3C1CC0F78}"/>
+                <a16:creationId xmlns:a16="http://schemas.microsoft.com/office/drawing/2014/main" id="{103A4718-2056-41F0-96D6-9820AFF16D5B}"/>
               </a:ext>
             </a:extLst>
           </p:cNvPr>
@@ -2958,7 +2958,7 @@
           <p:cNvPr id="2" name="Left column">
             <a:extLst xmlns:a="http://schemas.openxmlformats.org/drawingml/2006/main">
               <a:ext uri="{FF2B5EF4-FFF2-40B4-BE49-F238E27FC236}">
-                <a16:creationId xmlns:a16="http://schemas.microsoft.com/office/drawing/2014/main" id="{B361FE2F-44F1-41B3-B462-F37520EB51A5}"/>
+                <a16:creationId xmlns:a16="http://schemas.microsoft.com/office/drawing/2014/main" id="{8AD0AF70-7C1B-4FB7-B77D-8CCFAF8078BA}"/>
               </a:ext>
             </a:extLst>
           </p:cNvPr>
@@ -3153,12 +3153,12 @@
   </p:cSld>
   <p:clrMap bg1="lt1" tx1="dk1" bg2="lt2" tx2="dk2" accent1="accent1" accent2="accent2" accent3="accent3" accent4="accent4" accent5="accent5" accent6="accent6" hlink="hlink" folHlink="folHlink"/>
   <p:sldLayoutIdLst>
-    <p:sldLayoutId xmlns:r="http://schemas.openxmlformats.org/officeDocument/2006/relationships" id="2147483649" r:id="Raca82275dc2f4a87"/>
-    <p:sldLayoutId xmlns:r="http://schemas.openxmlformats.org/officeDocument/2006/relationships" id="2147483650" r:id="Rcfb6aeb80c534efd"/>
-    <p:sldLayoutId xmlns:r="http://schemas.openxmlformats.org/officeDocument/2006/relationships" id="2147483651" r:id="R7435a985d3924f06"/>
-    <p:sldLayoutId xmlns:r="http://schemas.openxmlformats.org/officeDocument/2006/relationships" id="2147483652" r:id="Redfc1ee1473d47b2"/>
-    <p:sldLayoutId xmlns:r="http://schemas.openxmlformats.org/officeDocument/2006/relationships" id="2147483653" r:id="R09931d85455e43c7"/>
-    <p:sldLayoutId xmlns:r="http://schemas.openxmlformats.org/officeDocument/2006/relationships" id="2147483654" r:id="R601da44665ab4987"/>
+    <p:sldLayoutId xmlns:r="http://schemas.openxmlformats.org/officeDocument/2006/relationships" id="2147483649" r:id="R548e1aa854c64c46"/>
+    <p:sldLayoutId xmlns:r="http://schemas.openxmlformats.org/officeDocument/2006/relationships" id="2147483650" r:id="R46843ad625bb41cb"/>
+    <p:sldLayoutId xmlns:r="http://schemas.openxmlformats.org/officeDocument/2006/relationships" id="2147483651" r:id="Raec89eab30934e98"/>
+    <p:sldLayoutId xmlns:r="http://schemas.openxmlformats.org/officeDocument/2006/relationships" id="2147483652" r:id="Rdf441bad19084601"/>
+    <p:sldLayoutId xmlns:r="http://schemas.openxmlformats.org/officeDocument/2006/relationships" id="2147483653" r:id="R49cb99e5112f4c82"/>
+    <p:sldLayoutId xmlns:r="http://schemas.openxmlformats.org/officeDocument/2006/relationships" id="2147483654" r:id="Rd702318daf0d4ab4"/>
   </p:sldLayoutIdLst>
   <p:txStyles>
     <p:titleStyle>
@@ -3709,7 +3709,7 @@
           <p:cNvPr id="8" name="">
             <a:extLst xmlns:a="http://schemas.openxmlformats.org/drawingml/2006/main">
               <a:ext uri="{FF2B5EF4-FFF2-40B4-BE49-F238E27FC236}">
-                <a16:creationId xmlns:a16="http://schemas.microsoft.com/office/drawing/2014/main" id="{AF0DE83E-F91B-4B4F-85A2-600E2672C56D}"/>
+                <a16:creationId xmlns:a16="http://schemas.microsoft.com/office/drawing/2014/main" id="{52792137-41C5-4EF3-9B7F-2F943EA8DD2C}"/>
               </a:ext>
             </a:extLst>
           </p:cNvPr>
@@ -3779,7 +3779,7 @@
           <p:cNvPr id="2" name="">
             <a:extLst xmlns:a="http://schemas.openxmlformats.org/drawingml/2006/main">
               <a:ext uri="{FF2B5EF4-FFF2-40B4-BE49-F238E27FC236}">
-                <a16:creationId xmlns:a16="http://schemas.microsoft.com/office/drawing/2014/main" id="{AB4A37B7-E174-49B2-A28D-460387F906C8}"/>
+                <a16:creationId xmlns:a16="http://schemas.microsoft.com/office/drawing/2014/main" id="{BC9C951C-E59A-4F01-9B6C-720E3DA2BC48}"/>
               </a:ext>
             </a:extLst>
           </p:cNvPr>
@@ -3809,7 +3809,7 @@
           <p:cNvPr id="3" name="">
             <a:extLst xmlns:a="http://schemas.openxmlformats.org/drawingml/2006/main">
               <a:ext uri="{FF2B5EF4-FFF2-40B4-BE49-F238E27FC236}">
-                <a16:creationId xmlns:a16="http://schemas.microsoft.com/office/drawing/2014/main" id="{06C1597C-074E-475F-821F-0ED2D3A444AD}"/>
+                <a16:creationId xmlns:a16="http://schemas.microsoft.com/office/drawing/2014/main" id="{B995EB77-F0E6-47D9-A49D-E4A4216520F2}"/>
               </a:ext>
             </a:extLst>
           </p:cNvPr>
@@ -3879,7 +3879,7 @@
           <p:cNvPr id="4" name="">
             <a:extLst xmlns:a="http://schemas.openxmlformats.org/drawingml/2006/main">
               <a:ext uri="{FF2B5EF4-FFF2-40B4-BE49-F238E27FC236}">
-                <a16:creationId xmlns:a16="http://schemas.microsoft.com/office/drawing/2014/main" id="{A2023B42-948B-41B8-B3FF-A0C9A928D92C}"/>
+                <a16:creationId xmlns:a16="http://schemas.microsoft.com/office/drawing/2014/main" id="{A7B29FD1-C850-4A86-9972-E7FCB01E70AB}"/>
               </a:ext>
             </a:extLst>
           </p:cNvPr>
@@ -3949,7 +3949,7 @@
           <p:cNvPr id="5" name="">
             <a:extLst xmlns:a="http://schemas.openxmlformats.org/drawingml/2006/main">
               <a:ext uri="{FF2B5EF4-FFF2-40B4-BE49-F238E27FC236}">
-                <a16:creationId xmlns:a16="http://schemas.microsoft.com/office/drawing/2014/main" id="{2D6F9A9D-EF37-43A9-BBFA-D6594803AC34}"/>
+                <a16:creationId xmlns:a16="http://schemas.microsoft.com/office/drawing/2014/main" id="{0BD44A5A-2F9B-4067-ABE8-E78DDF25AE7E}"/>
               </a:ext>
             </a:extLst>
           </p:cNvPr>
@@ -4046,7 +4046,7 @@
           <p:cNvPr id="6" name="">
             <a:extLst xmlns:a="http://schemas.openxmlformats.org/drawingml/2006/main">
               <a:ext uri="{FF2B5EF4-FFF2-40B4-BE49-F238E27FC236}">
-                <a16:creationId xmlns:a16="http://schemas.microsoft.com/office/drawing/2014/main" id="{69FECC39-EF7F-4EED-AA3E-69CE4CA57A0D}"/>
+                <a16:creationId xmlns:a16="http://schemas.microsoft.com/office/drawing/2014/main" id="{1B4DE7DF-D700-40AF-BF57-CCC882B147AD}"/>
               </a:ext>
             </a:extLst>
           </p:cNvPr>
@@ -4143,7 +4143,7 @@
           <p:cNvPr id="7" name="">
             <a:extLst xmlns:a="http://schemas.openxmlformats.org/drawingml/2006/main">
               <a:ext uri="{FF2B5EF4-FFF2-40B4-BE49-F238E27FC236}">
-                <a16:creationId xmlns:a16="http://schemas.microsoft.com/office/drawing/2014/main" id="{DFFCB2C0-5704-4B4D-9F2E-87708AE4557E}"/>
+                <a16:creationId xmlns:a16="http://schemas.microsoft.com/office/drawing/2014/main" id="{112E189B-D4BE-410E-8C2C-200C66FDEAB8}"/>
               </a:ext>
             </a:extLst>
           </p:cNvPr>
@@ -4211,7 +4211,7 @@
     </p:spTree>
     <p:extLst>
       <p:ext uri="{BB962C8B-B14F-4D97-AF65-F5344CB8AC3E}">
-        <p14:creationId xmlns:p14="http://schemas.microsoft.com/office/powerpoint/2010/main" val="502878717"/>
+        <p14:creationId xmlns:p14="http://schemas.microsoft.com/office/powerpoint/2010/main" val="507825530"/>
       </p:ext>
     </p:extLst>
   </p:cSld>
@@ -4242,7 +4242,7 @@
           <p:cNvPr id="12" name="">
             <a:extLst xmlns:a="http://schemas.openxmlformats.org/drawingml/2006/main">
               <a:ext uri="{FF2B5EF4-FFF2-40B4-BE49-F238E27FC236}">
-                <a16:creationId xmlns:a16="http://schemas.microsoft.com/office/drawing/2014/main" id="{3432D27B-E523-483C-8387-901547E2FE9F}"/>
+                <a16:creationId xmlns:a16="http://schemas.microsoft.com/office/drawing/2014/main" id="{15B9B0C9-EFA8-4A0F-86EA-572247574198}"/>
               </a:ext>
             </a:extLst>
           </p:cNvPr>
@@ -4312,7 +4312,7 @@
           <p:cNvPr id="2" name="">
             <a:extLst xmlns:a="http://schemas.openxmlformats.org/drawingml/2006/main">
               <a:ext uri="{FF2B5EF4-FFF2-40B4-BE49-F238E27FC236}">
-                <a16:creationId xmlns:a16="http://schemas.microsoft.com/office/drawing/2014/main" id="{7E25CC0A-280D-4357-985A-EFCAADBDB0AD}"/>
+                <a16:creationId xmlns:a16="http://schemas.microsoft.com/office/drawing/2014/main" id="{C2A0F99E-BB91-4C1E-9EF5-5985452CFDA6}"/>
               </a:ext>
             </a:extLst>
           </p:cNvPr>
@@ -4382,7 +4382,7 @@
           <p:cNvPr id="3" name="">
             <a:extLst xmlns:a="http://schemas.openxmlformats.org/drawingml/2006/main">
               <a:ext uri="{FF2B5EF4-FFF2-40B4-BE49-F238E27FC236}">
-                <a16:creationId xmlns:a16="http://schemas.microsoft.com/office/drawing/2014/main" id="{105DCC84-BFDD-4629-BA03-63E3E0C6DF76}"/>
+                <a16:creationId xmlns:a16="http://schemas.microsoft.com/office/drawing/2014/main" id="{BF3CAF12-0425-4A3E-BF81-CC523C40B168}"/>
               </a:ext>
             </a:extLst>
           </p:cNvPr>
@@ -4412,7 +4412,7 @@
           <p:cNvPr id="4" name="">
             <a:extLst xmlns:a="http://schemas.openxmlformats.org/drawingml/2006/main">
               <a:ext uri="{FF2B5EF4-FFF2-40B4-BE49-F238E27FC236}">
-                <a16:creationId xmlns:a16="http://schemas.microsoft.com/office/drawing/2014/main" id="{3E591F4C-D2E3-44D3-806F-713376A0EE7E}"/>
+                <a16:creationId xmlns:a16="http://schemas.microsoft.com/office/drawing/2014/main" id="{17CA6C73-E87A-4E26-B064-1AB77DA8BD62}"/>
               </a:ext>
             </a:extLst>
           </p:cNvPr>
@@ -4482,7 +4482,7 @@
           <p:cNvPr id="5" name="">
             <a:extLst xmlns:a="http://schemas.openxmlformats.org/drawingml/2006/main">
               <a:ext uri="{FF2B5EF4-FFF2-40B4-BE49-F238E27FC236}">
-                <a16:creationId xmlns:a16="http://schemas.microsoft.com/office/drawing/2014/main" id="{43361D79-0C27-4AF3-9407-D82A915915BE}"/>
+                <a16:creationId xmlns:a16="http://schemas.microsoft.com/office/drawing/2014/main" id="{4C34A9CE-15DA-448E-A5A5-D49938EDBDCC}"/>
               </a:ext>
             </a:extLst>
           </p:cNvPr>
@@ -4552,7 +4552,7 @@
           <p:cNvPr id="6" name="">
             <a:extLst xmlns:a="http://schemas.openxmlformats.org/drawingml/2006/main">
               <a:ext uri="{FF2B5EF4-FFF2-40B4-BE49-F238E27FC236}">
-                <a16:creationId xmlns:a16="http://schemas.microsoft.com/office/drawing/2014/main" id="{FE2AA3FC-C6F2-4F1E-B3ED-D1FEDBB4B679}"/>
+                <a16:creationId xmlns:a16="http://schemas.microsoft.com/office/drawing/2014/main" id="{6FE06271-3099-4560-BA15-AA2BCD8713AA}"/>
               </a:ext>
             </a:extLst>
           </p:cNvPr>
@@ -4622,7 +4622,7 @@
           <p:cNvPr id="7" name="">
             <a:extLst xmlns:a="http://schemas.openxmlformats.org/drawingml/2006/main">
               <a:ext uri="{FF2B5EF4-FFF2-40B4-BE49-F238E27FC236}">
-                <a16:creationId xmlns:a16="http://schemas.microsoft.com/office/drawing/2014/main" id="{2A2E4A1E-B737-48EB-98D6-91E5C7C1CBA8}"/>
+                <a16:creationId xmlns:a16="http://schemas.microsoft.com/office/drawing/2014/main" id="{C7DE1DCC-307E-4F59-AF90-D0837A346FF9}"/>
               </a:ext>
             </a:extLst>
           </p:cNvPr>
@@ -4692,7 +4692,7 @@
           <p:cNvPr id="8" name="">
             <a:extLst xmlns:a="http://schemas.openxmlformats.org/drawingml/2006/main">
               <a:ext uri="{FF2B5EF4-FFF2-40B4-BE49-F238E27FC236}">
-                <a16:creationId xmlns:a16="http://schemas.microsoft.com/office/drawing/2014/main" id="{B410A136-502B-48CA-B0AC-F6D840BC462E}"/>
+                <a16:creationId xmlns:a16="http://schemas.microsoft.com/office/drawing/2014/main" id="{47545DE8-14CE-4D97-A5B5-5B56630527DD}"/>
               </a:ext>
             </a:extLst>
           </p:cNvPr>
@@ -4762,7 +4762,7 @@
           <p:cNvPr id="9" name="">
             <a:extLst xmlns:a="http://schemas.openxmlformats.org/drawingml/2006/main">
               <a:ext uri="{FF2B5EF4-FFF2-40B4-BE49-F238E27FC236}">
-                <a16:creationId xmlns:a16="http://schemas.microsoft.com/office/drawing/2014/main" id="{AD33B2B4-49A7-4DCB-9C5A-D5D9D927A78C}"/>
+                <a16:creationId xmlns:a16="http://schemas.microsoft.com/office/drawing/2014/main" id="{713CF4DB-CB28-48ED-8EE8-C848BB4BEDE7}"/>
               </a:ext>
             </a:extLst>
           </p:cNvPr>
@@ -4832,7 +4832,7 @@
           <p:cNvPr id="10" name="">
             <a:extLst xmlns:a="http://schemas.openxmlformats.org/drawingml/2006/main">
               <a:ext uri="{FF2B5EF4-FFF2-40B4-BE49-F238E27FC236}">
-                <a16:creationId xmlns:a16="http://schemas.microsoft.com/office/drawing/2014/main" id="{09143ED9-162C-44F3-A25B-A0E30C8309A9}"/>
+                <a16:creationId xmlns:a16="http://schemas.microsoft.com/office/drawing/2014/main" id="{76963BAA-5FA2-492B-B074-71C757B4EF28}"/>
               </a:ext>
             </a:extLst>
           </p:cNvPr>
@@ -4902,7 +4902,7 @@
           <p:cNvPr id="11" name="">
             <a:extLst xmlns:a="http://schemas.openxmlformats.org/drawingml/2006/main">
               <a:ext uri="{FF2B5EF4-FFF2-40B4-BE49-F238E27FC236}">
-                <a16:creationId xmlns:a16="http://schemas.microsoft.com/office/drawing/2014/main" id="{371D88C0-82EE-42DC-A925-A9FBEF35A313}"/>
+                <a16:creationId xmlns:a16="http://schemas.microsoft.com/office/drawing/2014/main" id="{9397078D-FA9C-413B-841F-1D3145CCC03A}"/>
               </a:ext>
             </a:extLst>
           </p:cNvPr>
@@ -4970,7 +4970,7 @@
     </p:spTree>
     <p:extLst>
       <p:ext uri="{BB962C8B-B14F-4D97-AF65-F5344CB8AC3E}">
-        <p14:creationId xmlns:p14="http://schemas.microsoft.com/office/powerpoint/2010/main" val="1351710785"/>
+        <p14:creationId xmlns:p14="http://schemas.microsoft.com/office/powerpoint/2010/main" val="983548441"/>
       </p:ext>
     </p:extLst>
   </p:cSld>
@@ -5001,7 +5001,7 @@
           <p:cNvPr id="14" name="">
             <a:extLst xmlns:a="http://schemas.openxmlformats.org/drawingml/2006/main">
               <a:ext uri="{FF2B5EF4-FFF2-40B4-BE49-F238E27FC236}">
-                <a16:creationId xmlns:a16="http://schemas.microsoft.com/office/drawing/2014/main" id="{0852DC26-BC28-4148-9AEA-C3683045FE7E}"/>
+                <a16:creationId xmlns:a16="http://schemas.microsoft.com/office/drawing/2014/main" id="{593186CD-736B-44D6-9650-AC9378EAE008}"/>
               </a:ext>
             </a:extLst>
           </p:cNvPr>
@@ -5071,7 +5071,7 @@
           <p:cNvPr id="2" name="">
             <a:extLst xmlns:a="http://schemas.openxmlformats.org/drawingml/2006/main">
               <a:ext uri="{FF2B5EF4-FFF2-40B4-BE49-F238E27FC236}">
-                <a16:creationId xmlns:a16="http://schemas.microsoft.com/office/drawing/2014/main" id="{4947F349-CD77-463C-9083-3DFE5E802E63}"/>
+                <a16:creationId xmlns:a16="http://schemas.microsoft.com/office/drawing/2014/main" id="{B5C23932-C3F4-4114-BD0D-48AFF7E76579}"/>
               </a:ext>
             </a:extLst>
           </p:cNvPr>
@@ -5141,7 +5141,7 @@
           <p:cNvPr id="3" name="">
             <a:extLst xmlns:a="http://schemas.openxmlformats.org/drawingml/2006/main">
               <a:ext uri="{FF2B5EF4-FFF2-40B4-BE49-F238E27FC236}">
-                <a16:creationId xmlns:a16="http://schemas.microsoft.com/office/drawing/2014/main" id="{69308CFD-1E38-4480-9828-7D0643CB18DF}"/>
+                <a16:creationId xmlns:a16="http://schemas.microsoft.com/office/drawing/2014/main" id="{B78B438E-C71F-4B43-8803-A97D00B9F417}"/>
               </a:ext>
             </a:extLst>
           </p:cNvPr>
@@ -5171,7 +5171,7 @@
           <p:cNvPr id="4" name="">
             <a:extLst xmlns:a="http://schemas.openxmlformats.org/drawingml/2006/main">
               <a:ext uri="{FF2B5EF4-FFF2-40B4-BE49-F238E27FC236}">
-                <a16:creationId xmlns:a16="http://schemas.microsoft.com/office/drawing/2014/main" id="{5785A3B1-7B9C-40CA-8CFC-6D20CB71F72B}"/>
+                <a16:creationId xmlns:a16="http://schemas.microsoft.com/office/drawing/2014/main" id="{EFC7CE15-A4CB-4597-82D8-091B39828DF5}"/>
               </a:ext>
             </a:extLst>
           </p:cNvPr>
@@ -5241,7 +5241,7 @@
           <p:cNvPr id="5" name="">
             <a:extLst xmlns:a="http://schemas.openxmlformats.org/drawingml/2006/main">
               <a:ext uri="{FF2B5EF4-FFF2-40B4-BE49-F238E27FC236}">
-                <a16:creationId xmlns:a16="http://schemas.microsoft.com/office/drawing/2014/main" id="{F1F4758E-A2A2-4DEA-8C4D-E937CE9C81CF}"/>
+                <a16:creationId xmlns:a16="http://schemas.microsoft.com/office/drawing/2014/main" id="{104B263B-A1D6-4150-8732-9387A5B535F2}"/>
               </a:ext>
             </a:extLst>
           </p:cNvPr>
@@ -5311,7 +5311,7 @@
           <p:cNvPr id="6" name="">
             <a:extLst xmlns:a="http://schemas.openxmlformats.org/drawingml/2006/main">
               <a:ext uri="{FF2B5EF4-FFF2-40B4-BE49-F238E27FC236}">
-                <a16:creationId xmlns:a16="http://schemas.microsoft.com/office/drawing/2014/main" id="{FC156E14-1FB7-432B-9716-D9A65AD48069}"/>
+                <a16:creationId xmlns:a16="http://schemas.microsoft.com/office/drawing/2014/main" id="{FF918D02-C4E2-49C9-8B9A-62D9D0700FF1}"/>
               </a:ext>
             </a:extLst>
           </p:cNvPr>
@@ -5381,7 +5381,7 @@
           <p:cNvPr id="7" name="">
             <a:extLst xmlns:a="http://schemas.openxmlformats.org/drawingml/2006/main">
               <a:ext uri="{FF2B5EF4-FFF2-40B4-BE49-F238E27FC236}">
-                <a16:creationId xmlns:a16="http://schemas.microsoft.com/office/drawing/2014/main" id="{C71D8704-A3FD-4011-881D-D48EAFCCB719}"/>
+                <a16:creationId xmlns:a16="http://schemas.microsoft.com/office/drawing/2014/main" id="{A48C1AB3-F574-4339-B479-6E4F465E9AAA}"/>
               </a:ext>
             </a:extLst>
           </p:cNvPr>
@@ -5451,7 +5451,7 @@
           <p:cNvPr id="8" name="">
             <a:extLst xmlns:a="http://schemas.openxmlformats.org/drawingml/2006/main">
               <a:ext uri="{FF2B5EF4-FFF2-40B4-BE49-F238E27FC236}">
-                <a16:creationId xmlns:a16="http://schemas.microsoft.com/office/drawing/2014/main" id="{377676A1-D4FA-4058-878F-41806FFA66F1}"/>
+                <a16:creationId xmlns:a16="http://schemas.microsoft.com/office/drawing/2014/main" id="{A670D66C-8037-4978-A470-8E0FD718A754}"/>
               </a:ext>
             </a:extLst>
           </p:cNvPr>
@@ -5521,7 +5521,7 @@
           <p:cNvPr id="9" name="">
             <a:extLst xmlns:a="http://schemas.openxmlformats.org/drawingml/2006/main">
               <a:ext uri="{FF2B5EF4-FFF2-40B4-BE49-F238E27FC236}">
-                <a16:creationId xmlns:a16="http://schemas.microsoft.com/office/drawing/2014/main" id="{737581D4-CA3A-480E-97E3-A0F88DE1D4E0}"/>
+                <a16:creationId xmlns:a16="http://schemas.microsoft.com/office/drawing/2014/main" id="{6BEE2390-F4B6-4D08-A943-0D44D16AB8DB}"/>
               </a:ext>
             </a:extLst>
           </p:cNvPr>
@@ -5591,7 +5591,7 @@
           <p:cNvPr id="10" name="">
             <a:extLst xmlns:a="http://schemas.openxmlformats.org/drawingml/2006/main">
               <a:ext uri="{FF2B5EF4-FFF2-40B4-BE49-F238E27FC236}">
-                <a16:creationId xmlns:a16="http://schemas.microsoft.com/office/drawing/2014/main" id="{9F8B0FFE-3193-457D-872A-9464EA257574}"/>
+                <a16:creationId xmlns:a16="http://schemas.microsoft.com/office/drawing/2014/main" id="{F224C029-C168-4AAE-A32A-026E20B089A4}"/>
               </a:ext>
             </a:extLst>
           </p:cNvPr>
@@ -5661,7 +5661,7 @@
           <p:cNvPr id="11" name="">
             <a:extLst xmlns:a="http://schemas.openxmlformats.org/drawingml/2006/main">
               <a:ext uri="{FF2B5EF4-FFF2-40B4-BE49-F238E27FC236}">
-                <a16:creationId xmlns:a16="http://schemas.microsoft.com/office/drawing/2014/main" id="{9BFB32B8-E296-4995-8593-3D5DA8D1F123}"/>
+                <a16:creationId xmlns:a16="http://schemas.microsoft.com/office/drawing/2014/main" id="{0428E4BD-88E8-4B48-ABC5-B13701C518F7}"/>
               </a:ext>
             </a:extLst>
           </p:cNvPr>
@@ -5731,7 +5731,7 @@
           <p:cNvPr id="12" name="">
             <a:extLst xmlns:a="http://schemas.openxmlformats.org/drawingml/2006/main">
               <a:ext uri="{FF2B5EF4-FFF2-40B4-BE49-F238E27FC236}">
-                <a16:creationId xmlns:a16="http://schemas.microsoft.com/office/drawing/2014/main" id="{98531C61-087D-48B6-85FE-4E392074DBEB}"/>
+                <a16:creationId xmlns:a16="http://schemas.microsoft.com/office/drawing/2014/main" id="{DF24B76C-8155-4015-BAA6-BB20F1E6FA3E}"/>
               </a:ext>
             </a:extLst>
           </p:cNvPr>
@@ -5828,7 +5828,7 @@
           <p:cNvPr id="13" name="">
             <a:extLst xmlns:a="http://schemas.openxmlformats.org/drawingml/2006/main">
               <a:ext uri="{FF2B5EF4-FFF2-40B4-BE49-F238E27FC236}">
-                <a16:creationId xmlns:a16="http://schemas.microsoft.com/office/drawing/2014/main" id="{93EBA15E-E9C2-4924-8DD8-0A4AC03EA422}"/>
+                <a16:creationId xmlns:a16="http://schemas.microsoft.com/office/drawing/2014/main" id="{F004E271-5579-436A-A550-473E6EFCE75D}"/>
               </a:ext>
             </a:extLst>
           </p:cNvPr>
@@ -5950,7 +5950,7 @@
     </p:spTree>
     <p:extLst>
       <p:ext uri="{BB962C8B-B14F-4D97-AF65-F5344CB8AC3E}">
-        <p14:creationId xmlns:p14="http://schemas.microsoft.com/office/powerpoint/2010/main" val="973103416"/>
+        <p14:creationId xmlns:p14="http://schemas.microsoft.com/office/powerpoint/2010/main" val="892511637"/>
       </p:ext>
     </p:extLst>
   </p:cSld>
@@ -5981,7 +5981,7 @@
           <p:cNvPr id="12" name="">
             <a:extLst xmlns:a="http://schemas.openxmlformats.org/drawingml/2006/main">
               <a:ext uri="{FF2B5EF4-FFF2-40B4-BE49-F238E27FC236}">
-                <a16:creationId xmlns:a16="http://schemas.microsoft.com/office/drawing/2014/main" id="{30D0C34A-8FA3-4E88-AAB3-F2A339D32ACE}"/>
+                <a16:creationId xmlns:a16="http://schemas.microsoft.com/office/drawing/2014/main" id="{7BD8CC50-D212-4807-B6B7-B15153166734}"/>
               </a:ext>
             </a:extLst>
           </p:cNvPr>
@@ -6051,7 +6051,7 @@
           <p:cNvPr id="2" name="">
             <a:extLst xmlns:a="http://schemas.openxmlformats.org/drawingml/2006/main">
               <a:ext uri="{FF2B5EF4-FFF2-40B4-BE49-F238E27FC236}">
-                <a16:creationId xmlns:a16="http://schemas.microsoft.com/office/drawing/2014/main" id="{CBBE6960-5DF0-4796-B190-1E6FB41FB0FF}"/>
+                <a16:creationId xmlns:a16="http://schemas.microsoft.com/office/drawing/2014/main" id="{9AC7255F-2D8E-426D-BBA2-6962EDD25201}"/>
               </a:ext>
             </a:extLst>
           </p:cNvPr>
@@ -6121,7 +6121,7 @@
           <p:cNvPr id="3" name="">
             <a:extLst xmlns:a="http://schemas.openxmlformats.org/drawingml/2006/main">
               <a:ext uri="{FF2B5EF4-FFF2-40B4-BE49-F238E27FC236}">
-                <a16:creationId xmlns:a16="http://schemas.microsoft.com/office/drawing/2014/main" id="{5BD093BE-015B-45D0-9CE8-1421CEA0408E}"/>
+                <a16:creationId xmlns:a16="http://schemas.microsoft.com/office/drawing/2014/main" id="{8E474F09-2F1C-4CC8-94E7-DCD08D34BC3B}"/>
               </a:ext>
             </a:extLst>
           </p:cNvPr>
@@ -6151,7 +6151,7 @@
           <p:cNvPr id="4" name="">
             <a:extLst xmlns:a="http://schemas.openxmlformats.org/drawingml/2006/main">
               <a:ext uri="{FF2B5EF4-FFF2-40B4-BE49-F238E27FC236}">
-                <a16:creationId xmlns:a16="http://schemas.microsoft.com/office/drawing/2014/main" id="{0DCFAD64-3D18-40DF-AEEB-309218893021}"/>
+                <a16:creationId xmlns:a16="http://schemas.microsoft.com/office/drawing/2014/main" id="{530CE238-CC65-409F-BCE5-410040CBDEAD}"/>
               </a:ext>
             </a:extLst>
           </p:cNvPr>
@@ -6221,7 +6221,7 @@
           <p:cNvPr id="5" name="">
             <a:extLst xmlns:a="http://schemas.openxmlformats.org/drawingml/2006/main">
               <a:ext uri="{FF2B5EF4-FFF2-40B4-BE49-F238E27FC236}">
-                <a16:creationId xmlns:a16="http://schemas.microsoft.com/office/drawing/2014/main" id="{79B22D4B-6DE2-43E5-BD47-5E74AB911A07}"/>
+                <a16:creationId xmlns:a16="http://schemas.microsoft.com/office/drawing/2014/main" id="{9264CCE6-6828-4EDE-AFCB-7016E3F2A02E}"/>
               </a:ext>
             </a:extLst>
           </p:cNvPr>
@@ -6291,7 +6291,7 @@
           <p:cNvPr id="6" name="">
             <a:extLst xmlns:a="http://schemas.openxmlformats.org/drawingml/2006/main">
               <a:ext uri="{FF2B5EF4-FFF2-40B4-BE49-F238E27FC236}">
-                <a16:creationId xmlns:a16="http://schemas.microsoft.com/office/drawing/2014/main" id="{A5FC6924-AA1A-44DE-89B7-524F885AA8B3}"/>
+                <a16:creationId xmlns:a16="http://schemas.microsoft.com/office/drawing/2014/main" id="{8DFB9CD3-4C15-4FFF-A52D-AAFD03620878}"/>
               </a:ext>
             </a:extLst>
           </p:cNvPr>
@@ -6361,7 +6361,7 @@
           <p:cNvPr id="7" name="">
             <a:extLst xmlns:a="http://schemas.openxmlformats.org/drawingml/2006/main">
               <a:ext uri="{FF2B5EF4-FFF2-40B4-BE49-F238E27FC236}">
-                <a16:creationId xmlns:a16="http://schemas.microsoft.com/office/drawing/2014/main" id="{E722EA1D-41EA-49F7-9F16-F23D1AD00ECB}"/>
+                <a16:creationId xmlns:a16="http://schemas.microsoft.com/office/drawing/2014/main" id="{52B14158-6137-49C7-B098-82701BBBDA5F}"/>
               </a:ext>
             </a:extLst>
           </p:cNvPr>
@@ -6431,7 +6431,7 @@
           <p:cNvPr id="8" name="">
             <a:extLst xmlns:a="http://schemas.openxmlformats.org/drawingml/2006/main">
               <a:ext uri="{FF2B5EF4-FFF2-40B4-BE49-F238E27FC236}">
-                <a16:creationId xmlns:a16="http://schemas.microsoft.com/office/drawing/2014/main" id="{2514BE25-DCF1-441F-A65B-8952709E3D19}"/>
+                <a16:creationId xmlns:a16="http://schemas.microsoft.com/office/drawing/2014/main" id="{B4D3E19D-DED2-4C95-A455-48EF37BB9350}"/>
               </a:ext>
             </a:extLst>
           </p:cNvPr>
@@ -6501,7 +6501,7 @@
           <p:cNvPr id="9" name="">
             <a:extLst xmlns:a="http://schemas.openxmlformats.org/drawingml/2006/main">
               <a:ext uri="{FF2B5EF4-FFF2-40B4-BE49-F238E27FC236}">
-                <a16:creationId xmlns:a16="http://schemas.microsoft.com/office/drawing/2014/main" id="{8C819B36-9F76-46DF-8C05-5B30CEF3E36A}"/>
+                <a16:creationId xmlns:a16="http://schemas.microsoft.com/office/drawing/2014/main" id="{DC6B5C3B-EDCC-47D2-B489-CE44EC6E0E87}"/>
               </a:ext>
             </a:extLst>
           </p:cNvPr>
@@ -6571,7 +6571,7 @@
           <p:cNvPr id="10" name="">
             <a:extLst xmlns:a="http://schemas.openxmlformats.org/drawingml/2006/main">
               <a:ext uri="{FF2B5EF4-FFF2-40B4-BE49-F238E27FC236}">
-                <a16:creationId xmlns:a16="http://schemas.microsoft.com/office/drawing/2014/main" id="{51088B10-4927-44FC-A2FC-908634428D2E}"/>
+                <a16:creationId xmlns:a16="http://schemas.microsoft.com/office/drawing/2014/main" id="{F9252DD8-FF2E-4373-AEC8-6EE57CFB078E}"/>
               </a:ext>
             </a:extLst>
           </p:cNvPr>
@@ -6641,7 +6641,7 @@
           <p:cNvPr id="11" name="">
             <a:extLst xmlns:a="http://schemas.openxmlformats.org/drawingml/2006/main">
               <a:ext uri="{FF2B5EF4-FFF2-40B4-BE49-F238E27FC236}">
-                <a16:creationId xmlns:a16="http://schemas.microsoft.com/office/drawing/2014/main" id="{47D3A671-9406-4C81-92C1-7470B81B375A}"/>
+                <a16:creationId xmlns:a16="http://schemas.microsoft.com/office/drawing/2014/main" id="{3A3D1EFA-2B37-4B1D-A644-3BF2DE4D1CA2}"/>
               </a:ext>
             </a:extLst>
           </p:cNvPr>
@@ -6709,7 +6709,7 @@
     </p:spTree>
     <p:extLst>
       <p:ext uri="{BB962C8B-B14F-4D97-AF65-F5344CB8AC3E}">
-        <p14:creationId xmlns:p14="http://schemas.microsoft.com/office/powerpoint/2010/main" val="1531769955"/>
+        <p14:creationId xmlns:p14="http://schemas.microsoft.com/office/powerpoint/2010/main" val="1470131887"/>
       </p:ext>
     </p:extLst>
   </p:cSld>
@@ -6740,7 +6740,7 @@
           <p:cNvPr id="12" name="">
             <a:extLst xmlns:a="http://schemas.openxmlformats.org/drawingml/2006/main">
               <a:ext uri="{FF2B5EF4-FFF2-40B4-BE49-F238E27FC236}">
-                <a16:creationId xmlns:a16="http://schemas.microsoft.com/office/drawing/2014/main" id="{08DEDF54-389F-42D9-9AC2-85B2C6F6EDFD}"/>
+                <a16:creationId xmlns:a16="http://schemas.microsoft.com/office/drawing/2014/main" id="{2F471F3F-C236-4151-94BC-998B51D998AA}"/>
               </a:ext>
             </a:extLst>
           </p:cNvPr>
@@ -6810,7 +6810,7 @@
           <p:cNvPr id="2" name="">
             <a:extLst xmlns:a="http://schemas.openxmlformats.org/drawingml/2006/main">
               <a:ext uri="{FF2B5EF4-FFF2-40B4-BE49-F238E27FC236}">
-                <a16:creationId xmlns:a16="http://schemas.microsoft.com/office/drawing/2014/main" id="{42327F63-5384-4633-AAE0-8177ABCA7A9D}"/>
+                <a16:creationId xmlns:a16="http://schemas.microsoft.com/office/drawing/2014/main" id="{DA024252-E46D-4F8D-B500-EE36191402EC}"/>
               </a:ext>
             </a:extLst>
           </p:cNvPr>
@@ -6880,7 +6880,7 @@
           <p:cNvPr id="3" name="">
             <a:extLst xmlns:a="http://schemas.openxmlformats.org/drawingml/2006/main">
               <a:ext uri="{FF2B5EF4-FFF2-40B4-BE49-F238E27FC236}">
-                <a16:creationId xmlns:a16="http://schemas.microsoft.com/office/drawing/2014/main" id="{B9330B58-F283-4E59-B208-E5B5E10381BD}"/>
+                <a16:creationId xmlns:a16="http://schemas.microsoft.com/office/drawing/2014/main" id="{FC56FEDD-734A-4035-9A3E-050F6D992249}"/>
               </a:ext>
             </a:extLst>
           </p:cNvPr>
@@ -6910,7 +6910,7 @@
           <p:cNvPr id="4" name="">
             <a:extLst xmlns:a="http://schemas.openxmlformats.org/drawingml/2006/main">
               <a:ext uri="{FF2B5EF4-FFF2-40B4-BE49-F238E27FC236}">
-                <a16:creationId xmlns:a16="http://schemas.microsoft.com/office/drawing/2014/main" id="{F73AE26D-1FE2-430E-BFED-B0027BC263AD}"/>
+                <a16:creationId xmlns:a16="http://schemas.microsoft.com/office/drawing/2014/main" id="{36B41F49-2DD9-4DD3-BDC4-7E2502C3D2D5}"/>
               </a:ext>
             </a:extLst>
           </p:cNvPr>
@@ -6980,7 +6980,7 @@
           <p:cNvPr id="5" name="">
             <a:extLst xmlns:a="http://schemas.openxmlformats.org/drawingml/2006/main">
               <a:ext uri="{FF2B5EF4-FFF2-40B4-BE49-F238E27FC236}">
-                <a16:creationId xmlns:a16="http://schemas.microsoft.com/office/drawing/2014/main" id="{BD1F74D6-B9C6-4C3D-BDC0-0A2DDCA615CF}"/>
+                <a16:creationId xmlns:a16="http://schemas.microsoft.com/office/drawing/2014/main" id="{A19784E8-42D3-4203-B5C1-0D731F3DEBEF}"/>
               </a:ext>
             </a:extLst>
           </p:cNvPr>
@@ -7050,7 +7050,7 @@
           <p:cNvPr id="6" name="">
             <a:extLst xmlns:a="http://schemas.openxmlformats.org/drawingml/2006/main">
               <a:ext uri="{FF2B5EF4-FFF2-40B4-BE49-F238E27FC236}">
-                <a16:creationId xmlns:a16="http://schemas.microsoft.com/office/drawing/2014/main" id="{2BD7529B-C849-47BF-A10B-C7561C24BC17}"/>
+                <a16:creationId xmlns:a16="http://schemas.microsoft.com/office/drawing/2014/main" id="{5597DBD6-FDF4-4A14-92E8-B7639D55D882}"/>
               </a:ext>
             </a:extLst>
           </p:cNvPr>
@@ -7120,7 +7120,7 @@
           <p:cNvPr id="7" name="">
             <a:extLst xmlns:a="http://schemas.openxmlformats.org/drawingml/2006/main">
               <a:ext uri="{FF2B5EF4-FFF2-40B4-BE49-F238E27FC236}">
-                <a16:creationId xmlns:a16="http://schemas.microsoft.com/office/drawing/2014/main" id="{BC3EFC11-0F75-4B09-868D-129269C54D61}"/>
+                <a16:creationId xmlns:a16="http://schemas.microsoft.com/office/drawing/2014/main" id="{13581E67-5B24-4F3E-A5CE-135D47BBDD0C}"/>
               </a:ext>
             </a:extLst>
           </p:cNvPr>
@@ -7190,7 +7190,7 @@
           <p:cNvPr id="8" name="">
             <a:extLst xmlns:a="http://schemas.openxmlformats.org/drawingml/2006/main">
               <a:ext uri="{FF2B5EF4-FFF2-40B4-BE49-F238E27FC236}">
-                <a16:creationId xmlns:a16="http://schemas.microsoft.com/office/drawing/2014/main" id="{6EB324E9-07DD-481E-A926-050E0BDCA19A}"/>
+                <a16:creationId xmlns:a16="http://schemas.microsoft.com/office/drawing/2014/main" id="{94DCF934-D6F5-4A1A-9782-0F63D8A951ED}"/>
               </a:ext>
             </a:extLst>
           </p:cNvPr>
@@ -7260,7 +7260,7 @@
           <p:cNvPr id="9" name="">
             <a:extLst xmlns:a="http://schemas.openxmlformats.org/drawingml/2006/main">
               <a:ext uri="{FF2B5EF4-FFF2-40B4-BE49-F238E27FC236}">
-                <a16:creationId xmlns:a16="http://schemas.microsoft.com/office/drawing/2014/main" id="{4CC51935-9D9B-410A-B67C-27370134E1AE}"/>
+                <a16:creationId xmlns:a16="http://schemas.microsoft.com/office/drawing/2014/main" id="{1FDE16D2-DC9F-4D70-845A-02DF3931BAF1}"/>
               </a:ext>
             </a:extLst>
           </p:cNvPr>
@@ -7330,7 +7330,7 @@
           <p:cNvPr id="10" name="">
             <a:extLst xmlns:a="http://schemas.openxmlformats.org/drawingml/2006/main">
               <a:ext uri="{FF2B5EF4-FFF2-40B4-BE49-F238E27FC236}">
-                <a16:creationId xmlns:a16="http://schemas.microsoft.com/office/drawing/2014/main" id="{D9B23B16-D9EF-41D9-9646-3AEAE3DE1A5F}"/>
+                <a16:creationId xmlns:a16="http://schemas.microsoft.com/office/drawing/2014/main" id="{DAA2F53F-1093-41E6-B7A0-1297412DE1D1}"/>
               </a:ext>
             </a:extLst>
           </p:cNvPr>
@@ -7400,7 +7400,7 @@
           <p:cNvPr id="11" name="">
             <a:extLst xmlns:a="http://schemas.openxmlformats.org/drawingml/2006/main">
               <a:ext uri="{FF2B5EF4-FFF2-40B4-BE49-F238E27FC236}">
-                <a16:creationId xmlns:a16="http://schemas.microsoft.com/office/drawing/2014/main" id="{B79AE268-C100-44F9-932B-7628906D8B9A}"/>
+                <a16:creationId xmlns:a16="http://schemas.microsoft.com/office/drawing/2014/main" id="{4EABC4AC-E616-4B07-99F0-56406AEF2CB7}"/>
               </a:ext>
             </a:extLst>
           </p:cNvPr>
@@ -7468,7 +7468,7 @@
     </p:spTree>
     <p:extLst>
       <p:ext uri="{BB962C8B-B14F-4D97-AF65-F5344CB8AC3E}">
-        <p14:creationId xmlns:p14="http://schemas.microsoft.com/office/powerpoint/2010/main" val="342758634"/>
+        <p14:creationId xmlns:p14="http://schemas.microsoft.com/office/powerpoint/2010/main" val="1189444424"/>
       </p:ext>
     </p:extLst>
   </p:cSld>
@@ -7499,7 +7499,7 @@
           <p:cNvPr id="11" name="">
             <a:extLst xmlns:a="http://schemas.openxmlformats.org/drawingml/2006/main">
               <a:ext uri="{FF2B5EF4-FFF2-40B4-BE49-F238E27FC236}">
-                <a16:creationId xmlns:a16="http://schemas.microsoft.com/office/drawing/2014/main" id="{442C76D1-EAAB-480E-89C4-AB586258871F}"/>
+                <a16:creationId xmlns:a16="http://schemas.microsoft.com/office/drawing/2014/main" id="{56252208-CDDF-45BF-B6C7-5C2617AB2747}"/>
               </a:ext>
             </a:extLst>
           </p:cNvPr>
@@ -7569,7 +7569,7 @@
           <p:cNvPr id="2" name="">
             <a:extLst xmlns:a="http://schemas.openxmlformats.org/drawingml/2006/main">
               <a:ext uri="{FF2B5EF4-FFF2-40B4-BE49-F238E27FC236}">
-                <a16:creationId xmlns:a16="http://schemas.microsoft.com/office/drawing/2014/main" id="{FDBFA3FE-FC9A-474D-BE55-9F52E6261EE3}"/>
+                <a16:creationId xmlns:a16="http://schemas.microsoft.com/office/drawing/2014/main" id="{803C35CD-98A6-46B2-BE90-30E6B362D879}"/>
               </a:ext>
             </a:extLst>
           </p:cNvPr>
@@ -7639,7 +7639,7 @@
           <p:cNvPr id="3" name="">
             <a:extLst xmlns:a="http://schemas.openxmlformats.org/drawingml/2006/main">
               <a:ext uri="{FF2B5EF4-FFF2-40B4-BE49-F238E27FC236}">
-                <a16:creationId xmlns:a16="http://schemas.microsoft.com/office/drawing/2014/main" id="{B9AE6CBF-CAAB-4965-BE55-976A08E8B30D}"/>
+                <a16:creationId xmlns:a16="http://schemas.microsoft.com/office/drawing/2014/main" id="{B7EEDEE8-3263-4DC5-B670-B6F59C671C12}"/>
               </a:ext>
             </a:extLst>
           </p:cNvPr>
@@ -7669,7 +7669,7 @@
           <p:cNvPr id="4" name="">
             <a:extLst xmlns:a="http://schemas.openxmlformats.org/drawingml/2006/main">
               <a:ext uri="{FF2B5EF4-FFF2-40B4-BE49-F238E27FC236}">
-                <a16:creationId xmlns:a16="http://schemas.microsoft.com/office/drawing/2014/main" id="{DD3083F6-123B-4D90-B007-7E7D7B8E3DEB}"/>
+                <a16:creationId xmlns:a16="http://schemas.microsoft.com/office/drawing/2014/main" id="{6E9FFE88-CB45-4977-8D9D-562F3F97A074}"/>
               </a:ext>
             </a:extLst>
           </p:cNvPr>
@@ -7739,7 +7739,7 @@
           <p:cNvPr id="5" name="">
             <a:extLst xmlns:a="http://schemas.openxmlformats.org/drawingml/2006/main">
               <a:ext uri="{FF2B5EF4-FFF2-40B4-BE49-F238E27FC236}">
-                <a16:creationId xmlns:a16="http://schemas.microsoft.com/office/drawing/2014/main" id="{9D6262A6-1CCE-48CE-B98D-79E4C5BFAC3D}"/>
+                <a16:creationId xmlns:a16="http://schemas.microsoft.com/office/drawing/2014/main" id="{CC771E84-81A4-4836-9F4B-33EF67FB707D}"/>
               </a:ext>
             </a:extLst>
           </p:cNvPr>
@@ -7809,7 +7809,7 @@
           <p:cNvPr id="6" name="">
             <a:extLst xmlns:a="http://schemas.openxmlformats.org/drawingml/2006/main">
               <a:ext uri="{FF2B5EF4-FFF2-40B4-BE49-F238E27FC236}">
-                <a16:creationId xmlns:a16="http://schemas.microsoft.com/office/drawing/2014/main" id="{B4DD126D-60F7-4052-8E9E-338621F57713}"/>
+                <a16:creationId xmlns:a16="http://schemas.microsoft.com/office/drawing/2014/main" id="{9C881698-05D5-46F3-B153-3E06738F458F}"/>
               </a:ext>
             </a:extLst>
           </p:cNvPr>
@@ -7879,7 +7879,7 @@
           <p:cNvPr id="7" name="">
             <a:extLst xmlns:a="http://schemas.openxmlformats.org/drawingml/2006/main">
               <a:ext uri="{FF2B5EF4-FFF2-40B4-BE49-F238E27FC236}">
-                <a16:creationId xmlns:a16="http://schemas.microsoft.com/office/drawing/2014/main" id="{BB9BE2B0-DA19-4A5A-BE36-2D0B1E6BDA1A}"/>
+                <a16:creationId xmlns:a16="http://schemas.microsoft.com/office/drawing/2014/main" id="{B702C0E2-FF05-45B2-866D-2293E82DD37A}"/>
               </a:ext>
             </a:extLst>
           </p:cNvPr>
@@ -7949,7 +7949,7 @@
           <p:cNvPr id="8" name="">
             <a:extLst xmlns:a="http://schemas.openxmlformats.org/drawingml/2006/main">
               <a:ext uri="{FF2B5EF4-FFF2-40B4-BE49-F238E27FC236}">
-                <a16:creationId xmlns:a16="http://schemas.microsoft.com/office/drawing/2014/main" id="{0183501B-D1D5-4F03-B800-FB8958A58AFA}"/>
+                <a16:creationId xmlns:a16="http://schemas.microsoft.com/office/drawing/2014/main" id="{802A5193-6DD8-4784-9456-D2A5F0AD4E4A}"/>
               </a:ext>
             </a:extLst>
           </p:cNvPr>
@@ -8046,7 +8046,7 @@
           <p:cNvPr id="9" name="">
             <a:extLst xmlns:a="http://schemas.openxmlformats.org/drawingml/2006/main">
               <a:ext uri="{FF2B5EF4-FFF2-40B4-BE49-F238E27FC236}">
-                <a16:creationId xmlns:a16="http://schemas.microsoft.com/office/drawing/2014/main" id="{2A978822-CBA2-473A-8DA7-993E5E3CD890}"/>
+                <a16:creationId xmlns:a16="http://schemas.microsoft.com/office/drawing/2014/main" id="{E4EBD6E2-ADD5-46AE-97D1-56E67A254A04}"/>
               </a:ext>
             </a:extLst>
           </p:cNvPr>
@@ -8116,7 +8116,7 @@
           <p:cNvPr id="10" name="">
             <a:extLst xmlns:a="http://schemas.openxmlformats.org/drawingml/2006/main">
               <a:ext uri="{FF2B5EF4-FFF2-40B4-BE49-F238E27FC236}">
-                <a16:creationId xmlns:a16="http://schemas.microsoft.com/office/drawing/2014/main" id="{F857BEFD-F8FE-4D80-80BD-A2F426E7B8F4}"/>
+                <a16:creationId xmlns:a16="http://schemas.microsoft.com/office/drawing/2014/main" id="{763E2CB4-5D36-4998-9418-142FE42E8CD8}"/>
               </a:ext>
             </a:extLst>
           </p:cNvPr>
@@ -8126,7 +8126,7 @@
           <p:nvPr/>
         </p:nvPicPr>
         <p:blipFill>
-          <a:blip xmlns:r="http://schemas.openxmlformats.org/officeDocument/2006/relationships" xmlns:a="http://schemas.openxmlformats.org/drawingml/2006/main" r:embed="Rfbe00f5467ee4137"/>
+          <a:blip xmlns:r="http://schemas.openxmlformats.org/officeDocument/2006/relationships" xmlns:a="http://schemas.openxmlformats.org/drawingml/2006/main" r:embed="R57dfa4f00cc34fe7"/>
           <a:stretch xmlns:a="http://schemas.openxmlformats.org/drawingml/2006/main"/>
         </p:blipFill>
         <p:spPr>
@@ -8142,7 +8142,7 @@
     </p:spTree>
     <p:extLst>
       <p:ext uri="{BB962C8B-B14F-4D97-AF65-F5344CB8AC3E}">
-        <p14:creationId xmlns:p14="http://schemas.microsoft.com/office/powerpoint/2010/main" val="281783231"/>
+        <p14:creationId xmlns:p14="http://schemas.microsoft.com/office/powerpoint/2010/main" val="325938948"/>
       </p:ext>
     </p:extLst>
   </p:cSld>
@@ -8173,7 +8173,7 @@
           <p:cNvPr id="11" name="">
             <a:extLst xmlns:a="http://schemas.openxmlformats.org/drawingml/2006/main">
               <a:ext uri="{FF2B5EF4-FFF2-40B4-BE49-F238E27FC236}">
-                <a16:creationId xmlns:a16="http://schemas.microsoft.com/office/drawing/2014/main" id="{471B97FB-6849-413E-8006-F06A614A320C}"/>
+                <a16:creationId xmlns:a16="http://schemas.microsoft.com/office/drawing/2014/main" id="{92F77965-CA57-459F-B932-C085BABE3962}"/>
               </a:ext>
             </a:extLst>
           </p:cNvPr>
@@ -8243,7 +8243,7 @@
           <p:cNvPr id="2" name="">
             <a:extLst xmlns:a="http://schemas.openxmlformats.org/drawingml/2006/main">
               <a:ext uri="{FF2B5EF4-FFF2-40B4-BE49-F238E27FC236}">
-                <a16:creationId xmlns:a16="http://schemas.microsoft.com/office/drawing/2014/main" id="{AE3B4DEB-69A7-4CC7-8FF9-CBCFA30491C8}"/>
+                <a16:creationId xmlns:a16="http://schemas.microsoft.com/office/drawing/2014/main" id="{E5F9B3F0-DED1-4D0E-9A50-725B6C125015}"/>
               </a:ext>
             </a:extLst>
           </p:cNvPr>
@@ -8313,7 +8313,7 @@
           <p:cNvPr id="3" name="">
             <a:extLst xmlns:a="http://schemas.openxmlformats.org/drawingml/2006/main">
               <a:ext uri="{FF2B5EF4-FFF2-40B4-BE49-F238E27FC236}">
-                <a16:creationId xmlns:a16="http://schemas.microsoft.com/office/drawing/2014/main" id="{459763C3-6D19-4A93-AFDE-4D8AD31EE324}"/>
+                <a16:creationId xmlns:a16="http://schemas.microsoft.com/office/drawing/2014/main" id="{8A4EF941-F8BC-40C4-AF88-6D372ADF8B89}"/>
               </a:ext>
             </a:extLst>
           </p:cNvPr>
@@ -8343,7 +8343,7 @@
           <p:cNvPr id="4" name="">
             <a:extLst xmlns:a="http://schemas.openxmlformats.org/drawingml/2006/main">
               <a:ext uri="{FF2B5EF4-FFF2-40B4-BE49-F238E27FC236}">
-                <a16:creationId xmlns:a16="http://schemas.microsoft.com/office/drawing/2014/main" id="{2DBBE850-ED3C-453D-B5BB-4F00EDC362EE}"/>
+                <a16:creationId xmlns:a16="http://schemas.microsoft.com/office/drawing/2014/main" id="{D6FEA0B7-DC00-4DF8-B9E5-9DDE05D30ABF}"/>
               </a:ext>
             </a:extLst>
           </p:cNvPr>
@@ -8413,7 +8413,7 @@
           <p:cNvPr id="5" name="">
             <a:extLst xmlns:a="http://schemas.openxmlformats.org/drawingml/2006/main">
               <a:ext uri="{FF2B5EF4-FFF2-40B4-BE49-F238E27FC236}">
-                <a16:creationId xmlns:a16="http://schemas.microsoft.com/office/drawing/2014/main" id="{ADFC9DBA-C1CB-49D4-B0F8-C92E4733A796}"/>
+                <a16:creationId xmlns:a16="http://schemas.microsoft.com/office/drawing/2014/main" id="{2E42D991-2A51-4B35-ADF6-9BB2FB8D6497}"/>
               </a:ext>
             </a:extLst>
           </p:cNvPr>
@@ -8483,7 +8483,7 @@
           <p:cNvPr id="6" name="">
             <a:extLst xmlns:a="http://schemas.openxmlformats.org/drawingml/2006/main">
               <a:ext uri="{FF2B5EF4-FFF2-40B4-BE49-F238E27FC236}">
-                <a16:creationId xmlns:a16="http://schemas.microsoft.com/office/drawing/2014/main" id="{C0EA518A-24D4-42A8-9D67-9AC2E80BFCC0}"/>
+                <a16:creationId xmlns:a16="http://schemas.microsoft.com/office/drawing/2014/main" id="{5507262A-CAFB-4CF5-8A31-5B754C5DE36F}"/>
               </a:ext>
             </a:extLst>
           </p:cNvPr>
@@ -8493,7 +8493,7 @@
           <p:nvPr/>
         </p:nvPicPr>
         <p:blipFill>
-          <a:blip xmlns:r="http://schemas.openxmlformats.org/officeDocument/2006/relationships" xmlns:a="http://schemas.openxmlformats.org/drawingml/2006/main" r:embed="Reda3cff59b8d4e8d"/>
+          <a:blip xmlns:r="http://schemas.openxmlformats.org/officeDocument/2006/relationships" xmlns:a="http://schemas.openxmlformats.org/drawingml/2006/main" r:embed="Rb1d2914b31b0440b"/>
           <a:stretch xmlns:a="http://schemas.openxmlformats.org/drawingml/2006/main"/>
         </p:blipFill>
         <p:spPr>
@@ -8511,7 +8511,7 @@
           <p:cNvPr id="7" name="">
             <a:extLst xmlns:a="http://schemas.openxmlformats.org/drawingml/2006/main">
               <a:ext uri="{FF2B5EF4-FFF2-40B4-BE49-F238E27FC236}">
-                <a16:creationId xmlns:a16="http://schemas.microsoft.com/office/drawing/2014/main" id="{05300C6C-B0C1-495B-9A0E-BDA50C8E137C}"/>
+                <a16:creationId xmlns:a16="http://schemas.microsoft.com/office/drawing/2014/main" id="{310DA133-5B35-4D4D-9A43-0DEC4399B861}"/>
               </a:ext>
             </a:extLst>
           </p:cNvPr>
@@ -8608,7 +8608,7 @@
           <p:cNvPr id="8" name="">
             <a:extLst xmlns:a="http://schemas.openxmlformats.org/drawingml/2006/main">
               <a:ext uri="{FF2B5EF4-FFF2-40B4-BE49-F238E27FC236}">
-                <a16:creationId xmlns:a16="http://schemas.microsoft.com/office/drawing/2014/main" id="{041385D5-DC69-484E-87AE-D8A0C11F099D}"/>
+                <a16:creationId xmlns:a16="http://schemas.microsoft.com/office/drawing/2014/main" id="{D3A25959-46F3-4512-8A77-23F40F43F8A0}"/>
               </a:ext>
             </a:extLst>
           </p:cNvPr>
@@ -8678,7 +8678,7 @@
           <p:cNvPr id="9" name="">
             <a:extLst xmlns:a="http://schemas.openxmlformats.org/drawingml/2006/main">
               <a:ext uri="{FF2B5EF4-FFF2-40B4-BE49-F238E27FC236}">
-                <a16:creationId xmlns:a16="http://schemas.microsoft.com/office/drawing/2014/main" id="{FA8E16C7-2290-43A7-97C0-629F20884736}"/>
+                <a16:creationId xmlns:a16="http://schemas.microsoft.com/office/drawing/2014/main" id="{FD38D3B9-1794-4CE2-8094-C0AE174E0D9F}"/>
               </a:ext>
             </a:extLst>
           </p:cNvPr>
@@ -8748,7 +8748,7 @@
           <p:cNvPr id="10" name="">
             <a:extLst xmlns:a="http://schemas.openxmlformats.org/drawingml/2006/main">
               <a:ext uri="{FF2B5EF4-FFF2-40B4-BE49-F238E27FC236}">
-                <a16:creationId xmlns:a16="http://schemas.microsoft.com/office/drawing/2014/main" id="{9AC2F2E9-9B08-4107-A06A-42222DD623D6}"/>
+                <a16:creationId xmlns:a16="http://schemas.microsoft.com/office/drawing/2014/main" id="{CDD50337-C995-43F9-85F5-F8400C469683}"/>
               </a:ext>
             </a:extLst>
           </p:cNvPr>
@@ -8843,7 +8843,7 @@
     </p:spTree>
     <p:extLst>
       <p:ext uri="{BB962C8B-B14F-4D97-AF65-F5344CB8AC3E}">
-        <p14:creationId xmlns:p14="http://schemas.microsoft.com/office/powerpoint/2010/main" val="171384264"/>
+        <p14:creationId xmlns:p14="http://schemas.microsoft.com/office/powerpoint/2010/main" val="1528138216"/>
       </p:ext>
     </p:extLst>
   </p:cSld>
@@ -8874,7 +8874,7 @@
           <p:cNvPr id="10" name="">
             <a:extLst xmlns:a="http://schemas.openxmlformats.org/drawingml/2006/main">
               <a:ext uri="{FF2B5EF4-FFF2-40B4-BE49-F238E27FC236}">
-                <a16:creationId xmlns:a16="http://schemas.microsoft.com/office/drawing/2014/main" id="{4560C9B8-3F1C-440E-87A3-F7466F7154EF}"/>
+                <a16:creationId xmlns:a16="http://schemas.microsoft.com/office/drawing/2014/main" id="{58A1C641-F859-4806-BE1C-ADC24FA5AD80}"/>
               </a:ext>
             </a:extLst>
           </p:cNvPr>
@@ -8944,7 +8944,7 @@
           <p:cNvPr id="2" name="">
             <a:extLst xmlns:a="http://schemas.openxmlformats.org/drawingml/2006/main">
               <a:ext uri="{FF2B5EF4-FFF2-40B4-BE49-F238E27FC236}">
-                <a16:creationId xmlns:a16="http://schemas.microsoft.com/office/drawing/2014/main" id="{B927796E-4917-498E-B728-B80246CB069E}"/>
+                <a16:creationId xmlns:a16="http://schemas.microsoft.com/office/drawing/2014/main" id="{3FB2FA94-2297-4465-9636-017F4D51CFEC}"/>
               </a:ext>
             </a:extLst>
           </p:cNvPr>
@@ -9014,7 +9014,7 @@
           <p:cNvPr id="3" name="">
             <a:extLst xmlns:a="http://schemas.openxmlformats.org/drawingml/2006/main">
               <a:ext uri="{FF2B5EF4-FFF2-40B4-BE49-F238E27FC236}">
-                <a16:creationId xmlns:a16="http://schemas.microsoft.com/office/drawing/2014/main" id="{A89C8411-C114-4B12-BCF7-A95EDC06B278}"/>
+                <a16:creationId xmlns:a16="http://schemas.microsoft.com/office/drawing/2014/main" id="{ABDB650F-8854-43C1-8CE8-C88B920F2222}"/>
               </a:ext>
             </a:extLst>
           </p:cNvPr>
@@ -9044,7 +9044,7 @@
           <p:cNvPr id="4" name="">
             <a:extLst xmlns:a="http://schemas.openxmlformats.org/drawingml/2006/main">
               <a:ext uri="{FF2B5EF4-FFF2-40B4-BE49-F238E27FC236}">
-                <a16:creationId xmlns:a16="http://schemas.microsoft.com/office/drawing/2014/main" id="{76E1EF8D-CA2F-47F0-9C23-BA5DB61B5EB5}"/>
+                <a16:creationId xmlns:a16="http://schemas.microsoft.com/office/drawing/2014/main" id="{65EF8EAF-35F4-4C4B-914A-D0E249A593B1}"/>
               </a:ext>
             </a:extLst>
           </p:cNvPr>
@@ -9114,7 +9114,7 @@
           <p:cNvPr id="5" name="">
             <a:extLst xmlns:a="http://schemas.openxmlformats.org/drawingml/2006/main">
               <a:ext uri="{FF2B5EF4-FFF2-40B4-BE49-F238E27FC236}">
-                <a16:creationId xmlns:a16="http://schemas.microsoft.com/office/drawing/2014/main" id="{A0F40AE7-D924-40AA-B98A-707FA08B9ADC}"/>
+                <a16:creationId xmlns:a16="http://schemas.microsoft.com/office/drawing/2014/main" id="{95DE39F1-9A07-4821-80D6-FF13641588CF}"/>
               </a:ext>
             </a:extLst>
           </p:cNvPr>
@@ -9184,7 +9184,7 @@
           <p:cNvPr id="6" name="">
             <a:extLst xmlns:a="http://schemas.openxmlformats.org/drawingml/2006/main">
               <a:ext uri="{FF2B5EF4-FFF2-40B4-BE49-F238E27FC236}">
-                <a16:creationId xmlns:a16="http://schemas.microsoft.com/office/drawing/2014/main" id="{9C716C4F-CF28-4F6E-BC14-8180F7ADA5EF}"/>
+                <a16:creationId xmlns:a16="http://schemas.microsoft.com/office/drawing/2014/main" id="{3BD71B73-FB37-411F-A88A-3CBACC7E957F}"/>
               </a:ext>
             </a:extLst>
           </p:cNvPr>
@@ -9194,7 +9194,7 @@
           <p:nvPr/>
         </p:nvPicPr>
         <p:blipFill>
-          <a:blip xmlns:r="http://schemas.openxmlformats.org/officeDocument/2006/relationships" xmlns:a="http://schemas.openxmlformats.org/drawingml/2006/main" r:embed="Rffe0e64153294ff0"/>
+          <a:blip xmlns:r="http://schemas.openxmlformats.org/officeDocument/2006/relationships" xmlns:a="http://schemas.openxmlformats.org/drawingml/2006/main" r:embed="R00418d5d885c4e35"/>
           <a:stretch xmlns:a="http://schemas.openxmlformats.org/drawingml/2006/main"/>
         </p:blipFill>
         <p:spPr>
@@ -9212,7 +9212,7 @@
           <p:cNvPr id="7" name="">
             <a:extLst xmlns:a="http://schemas.openxmlformats.org/drawingml/2006/main">
               <a:ext uri="{FF2B5EF4-FFF2-40B4-BE49-F238E27FC236}">
-                <a16:creationId xmlns:a16="http://schemas.microsoft.com/office/drawing/2014/main" id="{84704094-EF89-4FF5-826A-092ADB09FDCD}"/>
+                <a16:creationId xmlns:a16="http://schemas.microsoft.com/office/drawing/2014/main" id="{8816006A-99A8-407A-8206-F48968763F98}"/>
               </a:ext>
             </a:extLst>
           </p:cNvPr>
@@ -9309,7 +9309,7 @@
           <p:cNvPr id="8" name="">
             <a:extLst xmlns:a="http://schemas.openxmlformats.org/drawingml/2006/main">
               <a:ext uri="{FF2B5EF4-FFF2-40B4-BE49-F238E27FC236}">
-                <a16:creationId xmlns:a16="http://schemas.microsoft.com/office/drawing/2014/main" id="{EC77023C-19FC-460F-BB3B-5B78FE93879E}"/>
+                <a16:creationId xmlns:a16="http://schemas.microsoft.com/office/drawing/2014/main" id="{41F837F9-F99D-4654-B056-6A4A517564DC}"/>
               </a:ext>
             </a:extLst>
           </p:cNvPr>
@@ -9406,7 +9406,7 @@
           <p:cNvPr id="9" name="">
             <a:extLst xmlns:a="http://schemas.openxmlformats.org/drawingml/2006/main">
               <a:ext uri="{FF2B5EF4-FFF2-40B4-BE49-F238E27FC236}">
-                <a16:creationId xmlns:a16="http://schemas.microsoft.com/office/drawing/2014/main" id="{475A009F-5394-4F64-A790-4A2499975CF3}"/>
+                <a16:creationId xmlns:a16="http://schemas.microsoft.com/office/drawing/2014/main" id="{82548EAE-A98C-414A-B87A-F4E608C318EB}"/>
               </a:ext>
             </a:extLst>
           </p:cNvPr>
@@ -9474,7 +9474,7 @@
     </p:spTree>
     <p:extLst>
       <p:ext uri="{BB962C8B-B14F-4D97-AF65-F5344CB8AC3E}">
-        <p14:creationId xmlns:p14="http://schemas.microsoft.com/office/powerpoint/2010/main" val="1999250112"/>
+        <p14:creationId xmlns:p14="http://schemas.microsoft.com/office/powerpoint/2010/main" val="1863535443"/>
       </p:ext>
     </p:extLst>
   </p:cSld>
@@ -9505,7 +9505,7 @@
           <p:cNvPr id="13" name="">
             <a:extLst xmlns:a="http://schemas.openxmlformats.org/drawingml/2006/main">
               <a:ext uri="{FF2B5EF4-FFF2-40B4-BE49-F238E27FC236}">
-                <a16:creationId xmlns:a16="http://schemas.microsoft.com/office/drawing/2014/main" id="{A75878BB-BF52-4B79-B363-059564B13FFE}"/>
+                <a16:creationId xmlns:a16="http://schemas.microsoft.com/office/drawing/2014/main" id="{D0F8AFD3-32DB-4BC7-97E2-BD79733F6597}"/>
               </a:ext>
             </a:extLst>
           </p:cNvPr>
@@ -9575,7 +9575,7 @@
           <p:cNvPr id="2" name="">
             <a:extLst xmlns:a="http://schemas.openxmlformats.org/drawingml/2006/main">
               <a:ext uri="{FF2B5EF4-FFF2-40B4-BE49-F238E27FC236}">
-                <a16:creationId xmlns:a16="http://schemas.microsoft.com/office/drawing/2014/main" id="{BA55DA5F-1C7E-4100-AD2B-05E7CE21E9FE}"/>
+                <a16:creationId xmlns:a16="http://schemas.microsoft.com/office/drawing/2014/main" id="{845F641D-743A-4F65-A4A1-4D173FAF130B}"/>
               </a:ext>
             </a:extLst>
           </p:cNvPr>
@@ -9645,7 +9645,7 @@
           <p:cNvPr id="3" name="">
             <a:extLst xmlns:a="http://schemas.openxmlformats.org/drawingml/2006/main">
               <a:ext uri="{FF2B5EF4-FFF2-40B4-BE49-F238E27FC236}">
-                <a16:creationId xmlns:a16="http://schemas.microsoft.com/office/drawing/2014/main" id="{69C0D7FA-D24A-4FEC-818F-3C94AF712878}"/>
+                <a16:creationId xmlns:a16="http://schemas.microsoft.com/office/drawing/2014/main" id="{788E8B2C-B4DC-4871-87F1-ADA4BFDBB09A}"/>
               </a:ext>
             </a:extLst>
           </p:cNvPr>
@@ -9675,7 +9675,7 @@
           <p:cNvPr id="4" name="">
             <a:extLst xmlns:a="http://schemas.openxmlformats.org/drawingml/2006/main">
               <a:ext uri="{FF2B5EF4-FFF2-40B4-BE49-F238E27FC236}">
-                <a16:creationId xmlns:a16="http://schemas.microsoft.com/office/drawing/2014/main" id="{645E2B6D-CB2D-48BC-BEC5-D9E3A5636526}"/>
+                <a16:creationId xmlns:a16="http://schemas.microsoft.com/office/drawing/2014/main" id="{32DC03B7-8222-450C-8228-552D8867EFAA}"/>
               </a:ext>
             </a:extLst>
           </p:cNvPr>
@@ -9745,7 +9745,7 @@
           <p:cNvPr id="5" name="">
             <a:extLst xmlns:a="http://schemas.openxmlformats.org/drawingml/2006/main">
               <a:ext uri="{FF2B5EF4-FFF2-40B4-BE49-F238E27FC236}">
-                <a16:creationId xmlns:a16="http://schemas.microsoft.com/office/drawing/2014/main" id="{DF846945-FBB3-4D5A-B77D-6D3406D53725}"/>
+                <a16:creationId xmlns:a16="http://schemas.microsoft.com/office/drawing/2014/main" id="{DC5D4356-620C-4D1B-BE5C-EAE2DB2E0DE9}"/>
               </a:ext>
             </a:extLst>
           </p:cNvPr>
@@ -9815,7 +9815,7 @@
           <p:cNvPr id="6" name="">
             <a:extLst xmlns:a="http://schemas.openxmlformats.org/drawingml/2006/main">
               <a:ext uri="{FF2B5EF4-FFF2-40B4-BE49-F238E27FC236}">
-                <a16:creationId xmlns:a16="http://schemas.microsoft.com/office/drawing/2014/main" id="{66FFA252-7F24-487D-8D21-B88100BF139F}"/>
+                <a16:creationId xmlns:a16="http://schemas.microsoft.com/office/drawing/2014/main" id="{AE34F253-EB21-40C8-86F0-FD5F2186B301}"/>
               </a:ext>
             </a:extLst>
           </p:cNvPr>
@@ -9825,7 +9825,7 @@
           <p:nvPr/>
         </p:nvPicPr>
         <p:blipFill>
-          <a:blip xmlns:r="http://schemas.openxmlformats.org/officeDocument/2006/relationships" xmlns:a="http://schemas.openxmlformats.org/drawingml/2006/main" r:embed="Ree3186276e884bbf"/>
+          <a:blip xmlns:r="http://schemas.openxmlformats.org/officeDocument/2006/relationships" xmlns:a="http://schemas.openxmlformats.org/drawingml/2006/main" r:embed="Rd860a4e5dbcb487d"/>
           <a:stretch xmlns:a="http://schemas.openxmlformats.org/drawingml/2006/main"/>
         </p:blipFill>
         <p:spPr>
@@ -9843,7 +9843,7 @@
           <p:cNvPr id="7" name="">
             <a:extLst xmlns:a="http://schemas.openxmlformats.org/drawingml/2006/main">
               <a:ext uri="{FF2B5EF4-FFF2-40B4-BE49-F238E27FC236}">
-                <a16:creationId xmlns:a16="http://schemas.microsoft.com/office/drawing/2014/main" id="{9CFFF59A-3423-43AE-B477-C9C74A46CCA5}"/>
+                <a16:creationId xmlns:a16="http://schemas.microsoft.com/office/drawing/2014/main" id="{DFD1C69F-1DF2-4FC5-935C-6EDEC8115184}"/>
               </a:ext>
             </a:extLst>
           </p:cNvPr>
@@ -9913,7 +9913,7 @@
           <p:cNvPr id="8" name="">
             <a:extLst xmlns:a="http://schemas.openxmlformats.org/drawingml/2006/main">
               <a:ext uri="{FF2B5EF4-FFF2-40B4-BE49-F238E27FC236}">
-                <a16:creationId xmlns:a16="http://schemas.microsoft.com/office/drawing/2014/main" id="{9151A07E-837C-431F-A533-E3B4F789C328}"/>
+                <a16:creationId xmlns:a16="http://schemas.microsoft.com/office/drawing/2014/main" id="{DFAADA52-5A1E-48C9-9B39-4E95063CBA7C}"/>
               </a:ext>
             </a:extLst>
           </p:cNvPr>
@@ -9983,7 +9983,7 @@
           <p:cNvPr id="9" name="">
             <a:extLst xmlns:a="http://schemas.openxmlformats.org/drawingml/2006/main">
               <a:ext uri="{FF2B5EF4-FFF2-40B4-BE49-F238E27FC236}">
-                <a16:creationId xmlns:a16="http://schemas.microsoft.com/office/drawing/2014/main" id="{EA6BA40E-B4FB-497B-9690-EA27447E0F1D}"/>
+                <a16:creationId xmlns:a16="http://schemas.microsoft.com/office/drawing/2014/main" id="{A9525DAE-4617-46B9-9C9C-E6131C249268}"/>
               </a:ext>
             </a:extLst>
           </p:cNvPr>
@@ -10053,7 +10053,7 @@
           <p:cNvPr id="10" name="">
             <a:extLst xmlns:a="http://schemas.openxmlformats.org/drawingml/2006/main">
               <a:ext uri="{FF2B5EF4-FFF2-40B4-BE49-F238E27FC236}">
-                <a16:creationId xmlns:a16="http://schemas.microsoft.com/office/drawing/2014/main" id="{18F2982C-1EDF-4790-BAB7-1CF2CBA16F9B}"/>
+                <a16:creationId xmlns:a16="http://schemas.microsoft.com/office/drawing/2014/main" id="{28D2EF79-7ED3-4F73-B482-21E12C24F55E}"/>
               </a:ext>
             </a:extLst>
           </p:cNvPr>
@@ -10123,7 +10123,7 @@
           <p:cNvPr id="11" name="">
             <a:extLst xmlns:a="http://schemas.openxmlformats.org/drawingml/2006/main">
               <a:ext uri="{FF2B5EF4-FFF2-40B4-BE49-F238E27FC236}">
-                <a16:creationId xmlns:a16="http://schemas.microsoft.com/office/drawing/2014/main" id="{FED1FA9A-5DDC-4B26-AE8C-A4A5FA63C55B}"/>
+                <a16:creationId xmlns:a16="http://schemas.microsoft.com/office/drawing/2014/main" id="{7ED2D2FF-9BE3-40F6-A01C-6F157BEDD6ED}"/>
               </a:ext>
             </a:extLst>
           </p:cNvPr>
@@ -10193,7 +10193,7 @@
           <p:cNvPr id="12" name="">
             <a:extLst xmlns:a="http://schemas.openxmlformats.org/drawingml/2006/main">
               <a:ext uri="{FF2B5EF4-FFF2-40B4-BE49-F238E27FC236}">
-                <a16:creationId xmlns:a16="http://schemas.microsoft.com/office/drawing/2014/main" id="{CD2C5515-1EE4-48BF-B423-583A8A64A947}"/>
+                <a16:creationId xmlns:a16="http://schemas.microsoft.com/office/drawing/2014/main" id="{4DB5241C-49DA-4D6B-9E35-F11337DEF6A7}"/>
               </a:ext>
             </a:extLst>
           </p:cNvPr>
@@ -10261,7 +10261,7 @@
     </p:spTree>
     <p:extLst>
       <p:ext uri="{BB962C8B-B14F-4D97-AF65-F5344CB8AC3E}">
-        <p14:creationId xmlns:p14="http://schemas.microsoft.com/office/powerpoint/2010/main" val="1331077731"/>
+        <p14:creationId xmlns:p14="http://schemas.microsoft.com/office/powerpoint/2010/main" val="699910971"/>
       </p:ext>
     </p:extLst>
   </p:cSld>
@@ -10292,7 +10292,7 @@
           <p:cNvPr id="19" name="">
             <a:extLst xmlns:a="http://schemas.openxmlformats.org/drawingml/2006/main">
               <a:ext uri="{FF2B5EF4-FFF2-40B4-BE49-F238E27FC236}">
-                <a16:creationId xmlns:a16="http://schemas.microsoft.com/office/drawing/2014/main" id="{02A9B15B-0E54-4681-ADF8-4325E3313837}"/>
+                <a16:creationId xmlns:a16="http://schemas.microsoft.com/office/drawing/2014/main" id="{DF579A4E-30D1-4AE6-A098-190194D4694B}"/>
               </a:ext>
             </a:extLst>
           </p:cNvPr>
@@ -10362,7 +10362,7 @@
           <p:cNvPr id="2" name="">
             <a:extLst xmlns:a="http://schemas.openxmlformats.org/drawingml/2006/main">
               <a:ext uri="{FF2B5EF4-FFF2-40B4-BE49-F238E27FC236}">
-                <a16:creationId xmlns:a16="http://schemas.microsoft.com/office/drawing/2014/main" id="{37C7FBA6-0F0F-4814-84FD-5C841663FFA9}"/>
+                <a16:creationId xmlns:a16="http://schemas.microsoft.com/office/drawing/2014/main" id="{A7842C0E-4FD4-4DC0-A1F5-D3E2DE4A3A33}"/>
               </a:ext>
             </a:extLst>
           </p:cNvPr>
@@ -10432,7 +10432,7 @@
           <p:cNvPr id="3" name="">
             <a:extLst xmlns:a="http://schemas.openxmlformats.org/drawingml/2006/main">
               <a:ext uri="{FF2B5EF4-FFF2-40B4-BE49-F238E27FC236}">
-                <a16:creationId xmlns:a16="http://schemas.microsoft.com/office/drawing/2014/main" id="{EF5B9590-85E3-4FAA-ACC4-AE71DA906300}"/>
+                <a16:creationId xmlns:a16="http://schemas.microsoft.com/office/drawing/2014/main" id="{8582056E-C249-4B08-A173-FACC54041019}"/>
               </a:ext>
             </a:extLst>
           </p:cNvPr>
@@ -10462,7 +10462,7 @@
           <p:cNvPr id="4" name="">
             <a:extLst xmlns:a="http://schemas.openxmlformats.org/drawingml/2006/main">
               <a:ext uri="{FF2B5EF4-FFF2-40B4-BE49-F238E27FC236}">
-                <a16:creationId xmlns:a16="http://schemas.microsoft.com/office/drawing/2014/main" id="{010250C4-1662-4823-8616-354C8F1A2E40}"/>
+                <a16:creationId xmlns:a16="http://schemas.microsoft.com/office/drawing/2014/main" id="{B57DDE94-D6C7-4956-A121-84901955FD0A}"/>
               </a:ext>
             </a:extLst>
           </p:cNvPr>
@@ -10532,7 +10532,7 @@
           <p:cNvPr id="5" name="">
             <a:extLst xmlns:a="http://schemas.openxmlformats.org/drawingml/2006/main">
               <a:ext uri="{FF2B5EF4-FFF2-40B4-BE49-F238E27FC236}">
-                <a16:creationId xmlns:a16="http://schemas.microsoft.com/office/drawing/2014/main" id="{1892B6F8-233A-42FC-BAFF-D09280C46B7B}"/>
+                <a16:creationId xmlns:a16="http://schemas.microsoft.com/office/drawing/2014/main" id="{6DD86DBF-F619-4AD3-B1B5-7FD58665D78D}"/>
               </a:ext>
             </a:extLst>
           </p:cNvPr>
@@ -10602,7 +10602,7 @@
           <p:cNvPr id="6" name="">
             <a:extLst xmlns:a="http://schemas.openxmlformats.org/drawingml/2006/main">
               <a:ext uri="{FF2B5EF4-FFF2-40B4-BE49-F238E27FC236}">
-                <a16:creationId xmlns:a16="http://schemas.microsoft.com/office/drawing/2014/main" id="{AA543AFF-A2A2-47F5-A806-0A3E92206233}"/>
+                <a16:creationId xmlns:a16="http://schemas.microsoft.com/office/drawing/2014/main" id="{9DB4A790-CB2D-41DD-AE15-1F7D75461B3B}"/>
               </a:ext>
             </a:extLst>
           </p:cNvPr>
@@ -10672,7 +10672,7 @@
           <p:cNvPr id="7" name="">
             <a:extLst xmlns:a="http://schemas.openxmlformats.org/drawingml/2006/main">
               <a:ext uri="{FF2B5EF4-FFF2-40B4-BE49-F238E27FC236}">
-                <a16:creationId xmlns:a16="http://schemas.microsoft.com/office/drawing/2014/main" id="{39EEE4B5-1E9C-4CC0-AC0B-B4BB3E8ADB69}"/>
+                <a16:creationId xmlns:a16="http://schemas.microsoft.com/office/drawing/2014/main" id="{A4C1A6E4-6BB9-41F2-80A9-468C21A6AE2C}"/>
               </a:ext>
             </a:extLst>
           </p:cNvPr>
@@ -10742,7 +10742,7 @@
           <p:cNvPr id="8" name="">
             <a:extLst xmlns:a="http://schemas.openxmlformats.org/drawingml/2006/main">
               <a:ext uri="{FF2B5EF4-FFF2-40B4-BE49-F238E27FC236}">
-                <a16:creationId xmlns:a16="http://schemas.microsoft.com/office/drawing/2014/main" id="{1A67B2D7-B39E-4DA8-8D7C-3B46FD974DDA}"/>
+                <a16:creationId xmlns:a16="http://schemas.microsoft.com/office/drawing/2014/main" id="{C90F3F1B-A3B0-4E12-A325-FE9A3F141133}"/>
               </a:ext>
             </a:extLst>
           </p:cNvPr>
@@ -10812,7 +10812,7 @@
           <p:cNvPr id="9" name="">
             <a:extLst xmlns:a="http://schemas.openxmlformats.org/drawingml/2006/main">
               <a:ext uri="{FF2B5EF4-FFF2-40B4-BE49-F238E27FC236}">
-                <a16:creationId xmlns:a16="http://schemas.microsoft.com/office/drawing/2014/main" id="{E2802DD4-B8FB-49FD-B274-1349EE77B8BB}"/>
+                <a16:creationId xmlns:a16="http://schemas.microsoft.com/office/drawing/2014/main" id="{CAF5B476-6A62-49DD-BBC6-974E4835C4A1}"/>
               </a:ext>
             </a:extLst>
           </p:cNvPr>
@@ -10882,7 +10882,7 @@
           <p:cNvPr id="10" name="">
             <a:extLst xmlns:a="http://schemas.openxmlformats.org/drawingml/2006/main">
               <a:ext uri="{FF2B5EF4-FFF2-40B4-BE49-F238E27FC236}">
-                <a16:creationId xmlns:a16="http://schemas.microsoft.com/office/drawing/2014/main" id="{31D95CE2-B3AF-49D0-BBCA-AB0A9480B428}"/>
+                <a16:creationId xmlns:a16="http://schemas.microsoft.com/office/drawing/2014/main" id="{56E1DE11-D4E2-4395-9B76-BE3BB81C77D8}"/>
               </a:ext>
             </a:extLst>
           </p:cNvPr>
@@ -10952,7 +10952,7 @@
           <p:cNvPr id="11" name="">
             <a:extLst xmlns:a="http://schemas.openxmlformats.org/drawingml/2006/main">
               <a:ext uri="{FF2B5EF4-FFF2-40B4-BE49-F238E27FC236}">
-                <a16:creationId xmlns:a16="http://schemas.microsoft.com/office/drawing/2014/main" id="{8837F2D9-738D-4A25-B20C-8A1635A01B3B}"/>
+                <a16:creationId xmlns:a16="http://schemas.microsoft.com/office/drawing/2014/main" id="{A65F3F73-BDF5-459F-9605-B415F25ED93B}"/>
               </a:ext>
             </a:extLst>
           </p:cNvPr>
@@ -11022,7 +11022,7 @@
           <p:cNvPr id="12" name="">
             <a:extLst xmlns:a="http://schemas.openxmlformats.org/drawingml/2006/main">
               <a:ext uri="{FF2B5EF4-FFF2-40B4-BE49-F238E27FC236}">
-                <a16:creationId xmlns:a16="http://schemas.microsoft.com/office/drawing/2014/main" id="{E740E0E5-9147-4831-B528-E513B4CFA04D}"/>
+                <a16:creationId xmlns:a16="http://schemas.microsoft.com/office/drawing/2014/main" id="{79E6FDC4-EBEA-4A57-A968-D922F6A863BD}"/>
               </a:ext>
             </a:extLst>
           </p:cNvPr>
@@ -11092,7 +11092,7 @@
           <p:cNvPr id="13" name="">
             <a:extLst xmlns:a="http://schemas.openxmlformats.org/drawingml/2006/main">
               <a:ext uri="{FF2B5EF4-FFF2-40B4-BE49-F238E27FC236}">
-                <a16:creationId xmlns:a16="http://schemas.microsoft.com/office/drawing/2014/main" id="{2FB50936-06DD-4931-BFB3-140910B41120}"/>
+                <a16:creationId xmlns:a16="http://schemas.microsoft.com/office/drawing/2014/main" id="{47F09E2D-D108-4F6D-903D-7693FCCCB1E2}"/>
               </a:ext>
             </a:extLst>
           </p:cNvPr>
@@ -11162,7 +11162,7 @@
           <p:cNvPr id="14" name="">
             <a:extLst xmlns:a="http://schemas.openxmlformats.org/drawingml/2006/main">
               <a:ext uri="{FF2B5EF4-FFF2-40B4-BE49-F238E27FC236}">
-                <a16:creationId xmlns:a16="http://schemas.microsoft.com/office/drawing/2014/main" id="{996047BC-8052-4702-BA55-1D9E35FD1CE9}"/>
+                <a16:creationId xmlns:a16="http://schemas.microsoft.com/office/drawing/2014/main" id="{C5764132-734F-43A2-B01A-260AE8800822}"/>
               </a:ext>
             </a:extLst>
           </p:cNvPr>
@@ -11232,7 +11232,7 @@
           <p:cNvPr id="15" name="">
             <a:extLst xmlns:a="http://schemas.openxmlformats.org/drawingml/2006/main">
               <a:ext uri="{FF2B5EF4-FFF2-40B4-BE49-F238E27FC236}">
-                <a16:creationId xmlns:a16="http://schemas.microsoft.com/office/drawing/2014/main" id="{516F3F75-497D-4A29-90D7-2C9CE96E94B2}"/>
+                <a16:creationId xmlns:a16="http://schemas.microsoft.com/office/drawing/2014/main" id="{871424C6-22EC-4FF5-B659-4BF0D19BAE66}"/>
               </a:ext>
             </a:extLst>
           </p:cNvPr>
@@ -11302,7 +11302,7 @@
           <p:cNvPr id="16" name="">
             <a:extLst xmlns:a="http://schemas.openxmlformats.org/drawingml/2006/main">
               <a:ext uri="{FF2B5EF4-FFF2-40B4-BE49-F238E27FC236}">
-                <a16:creationId xmlns:a16="http://schemas.microsoft.com/office/drawing/2014/main" id="{E1840322-0F9E-41B3-B0D6-8BFA6BF815D6}"/>
+                <a16:creationId xmlns:a16="http://schemas.microsoft.com/office/drawing/2014/main" id="{29F4786C-2E8F-466C-BD9D-6D57EA07958D}"/>
               </a:ext>
             </a:extLst>
           </p:cNvPr>
@@ -11372,7 +11372,7 @@
           <p:cNvPr id="17" name="">
             <a:extLst xmlns:a="http://schemas.openxmlformats.org/drawingml/2006/main">
               <a:ext uri="{FF2B5EF4-FFF2-40B4-BE49-F238E27FC236}">
-                <a16:creationId xmlns:a16="http://schemas.microsoft.com/office/drawing/2014/main" id="{1BF6EE35-BF2B-4C89-9B68-6B44A09387D3}"/>
+                <a16:creationId xmlns:a16="http://schemas.microsoft.com/office/drawing/2014/main" id="{AA6E40E9-9BA8-46C1-B19C-441ED9A4A515}"/>
               </a:ext>
             </a:extLst>
           </p:cNvPr>
@@ -11442,7 +11442,7 @@
           <p:cNvPr id="18" name="">
             <a:extLst xmlns:a="http://schemas.openxmlformats.org/drawingml/2006/main">
               <a:ext uri="{FF2B5EF4-FFF2-40B4-BE49-F238E27FC236}">
-                <a16:creationId xmlns:a16="http://schemas.microsoft.com/office/drawing/2014/main" id="{AF4389DE-7C0A-4D6B-AB85-683BDEB99B8E}"/>
+                <a16:creationId xmlns:a16="http://schemas.microsoft.com/office/drawing/2014/main" id="{7592D277-D8AF-4CAD-A917-C8B04AB66A8C}"/>
               </a:ext>
             </a:extLst>
           </p:cNvPr>
@@ -11510,7 +11510,7 @@
     </p:spTree>
     <p:extLst>
       <p:ext uri="{BB962C8B-B14F-4D97-AF65-F5344CB8AC3E}">
-        <p14:creationId xmlns:p14="http://schemas.microsoft.com/office/powerpoint/2010/main" val="887286808"/>
+        <p14:creationId xmlns:p14="http://schemas.microsoft.com/office/powerpoint/2010/main" val="1713219904"/>
       </p:ext>
     </p:extLst>
   </p:cSld>
@@ -11541,7 +11541,7 @@
           <p:cNvPr id="9" name="">
             <a:extLst xmlns:a="http://schemas.openxmlformats.org/drawingml/2006/main">
               <a:ext uri="{FF2B5EF4-FFF2-40B4-BE49-F238E27FC236}">
-                <a16:creationId xmlns:a16="http://schemas.microsoft.com/office/drawing/2014/main" id="{6418D86A-17CD-4946-BA87-92EEE5E088EA}"/>
+                <a16:creationId xmlns:a16="http://schemas.microsoft.com/office/drawing/2014/main" id="{5C3C2416-B8AC-4CC2-B9BD-3059A451F2E0}"/>
               </a:ext>
             </a:extLst>
           </p:cNvPr>
@@ -11611,7 +11611,7 @@
           <p:cNvPr id="2" name="">
             <a:extLst xmlns:a="http://schemas.openxmlformats.org/drawingml/2006/main">
               <a:ext uri="{FF2B5EF4-FFF2-40B4-BE49-F238E27FC236}">
-                <a16:creationId xmlns:a16="http://schemas.microsoft.com/office/drawing/2014/main" id="{D1C0C8C0-49A3-4C91-B2CD-47948A06D33D}"/>
+                <a16:creationId xmlns:a16="http://schemas.microsoft.com/office/drawing/2014/main" id="{D566D0A8-C6BD-48D0-AA84-EFBF5EFC0AC1}"/>
               </a:ext>
             </a:extLst>
           </p:cNvPr>
@@ -11681,7 +11681,7 @@
           <p:cNvPr id="3" name="">
             <a:extLst xmlns:a="http://schemas.openxmlformats.org/drawingml/2006/main">
               <a:ext uri="{FF2B5EF4-FFF2-40B4-BE49-F238E27FC236}">
-                <a16:creationId xmlns:a16="http://schemas.microsoft.com/office/drawing/2014/main" id="{9098775C-5C7E-4E40-AB66-7425D47EF3CD}"/>
+                <a16:creationId xmlns:a16="http://schemas.microsoft.com/office/drawing/2014/main" id="{2878F6E9-3A84-4812-8011-09B8DD6C3D5A}"/>
               </a:ext>
             </a:extLst>
           </p:cNvPr>
@@ -11711,7 +11711,7 @@
           <p:cNvPr id="4" name="">
             <a:extLst xmlns:a="http://schemas.openxmlformats.org/drawingml/2006/main">
               <a:ext uri="{FF2B5EF4-FFF2-40B4-BE49-F238E27FC236}">
-                <a16:creationId xmlns:a16="http://schemas.microsoft.com/office/drawing/2014/main" id="{FC43A943-0CF6-4170-BE49-33ACEF121C5B}"/>
+                <a16:creationId xmlns:a16="http://schemas.microsoft.com/office/drawing/2014/main" id="{7690AA39-7BAE-4B05-9ED6-E1E4E6B6D7A9}"/>
               </a:ext>
             </a:extLst>
           </p:cNvPr>
@@ -11781,7 +11781,7 @@
           <p:cNvPr id="5" name="">
             <a:extLst xmlns:a="http://schemas.openxmlformats.org/drawingml/2006/main">
               <a:ext uri="{FF2B5EF4-FFF2-40B4-BE49-F238E27FC236}">
-                <a16:creationId xmlns:a16="http://schemas.microsoft.com/office/drawing/2014/main" id="{F8E042DC-F022-45BC-869C-68B1386264A8}"/>
+                <a16:creationId xmlns:a16="http://schemas.microsoft.com/office/drawing/2014/main" id="{D732C1AC-51F9-4E21-B324-9561C9D87F22}"/>
               </a:ext>
             </a:extLst>
           </p:cNvPr>
@@ -11851,7 +11851,7 @@
           <p:cNvPr id="6" name="">
             <a:extLst xmlns:a="http://schemas.openxmlformats.org/drawingml/2006/main">
               <a:ext uri="{FF2B5EF4-FFF2-40B4-BE49-F238E27FC236}">
-                <a16:creationId xmlns:a16="http://schemas.microsoft.com/office/drawing/2014/main" id="{24515B38-6796-4A04-BEA3-B902A25CA0D6}"/>
+                <a16:creationId xmlns:a16="http://schemas.microsoft.com/office/drawing/2014/main" id="{E918D3A1-63FB-4BFB-9980-66A44D56D516}"/>
               </a:ext>
             </a:extLst>
           </p:cNvPr>
@@ -12083,7 +12083,7 @@
           <p:cNvPr id="7" name="">
             <a:extLst xmlns:a="http://schemas.openxmlformats.org/drawingml/2006/main">
               <a:ext uri="{FF2B5EF4-FFF2-40B4-BE49-F238E27FC236}">
-                <a16:creationId xmlns:a16="http://schemas.microsoft.com/office/drawing/2014/main" id="{CD3C63FA-FEA4-477B-ACCC-C3182C2E5FB5}"/>
+                <a16:creationId xmlns:a16="http://schemas.microsoft.com/office/drawing/2014/main" id="{D76B701E-7C8D-4492-B7CF-EE706358EE65}"/>
               </a:ext>
             </a:extLst>
           </p:cNvPr>
@@ -12261,7 +12261,7 @@
           <p:cNvPr id="8" name="">
             <a:extLst xmlns:a="http://schemas.openxmlformats.org/drawingml/2006/main">
               <a:ext uri="{FF2B5EF4-FFF2-40B4-BE49-F238E27FC236}">
-                <a16:creationId xmlns:a16="http://schemas.microsoft.com/office/drawing/2014/main" id="{173B5F04-7AEB-4A56-B4F3-B21CF642C8C6}"/>
+                <a16:creationId xmlns:a16="http://schemas.microsoft.com/office/drawing/2014/main" id="{66AFFA93-4197-44F8-B3AD-EAE33D256D79}"/>
               </a:ext>
             </a:extLst>
           </p:cNvPr>
@@ -12329,7 +12329,7 @@
     </p:spTree>
     <p:extLst>
       <p:ext uri="{BB962C8B-B14F-4D97-AF65-F5344CB8AC3E}">
-        <p14:creationId xmlns:p14="http://schemas.microsoft.com/office/powerpoint/2010/main" val="229308396"/>
+        <p14:creationId xmlns:p14="http://schemas.microsoft.com/office/powerpoint/2010/main" val="574014682"/>
       </p:ext>
     </p:extLst>
   </p:cSld>
@@ -12360,7 +12360,7 @@
           <p:cNvPr id="12" name="">
             <a:extLst xmlns:a="http://schemas.openxmlformats.org/drawingml/2006/main">
               <a:ext uri="{FF2B5EF4-FFF2-40B4-BE49-F238E27FC236}">
-                <a16:creationId xmlns:a16="http://schemas.microsoft.com/office/drawing/2014/main" id="{2B9CC4DC-D4DE-43D0-A2E1-084B19D22B15}"/>
+                <a16:creationId xmlns:a16="http://schemas.microsoft.com/office/drawing/2014/main" id="{BB4AE70A-4ADF-44DC-8B71-3E781526B386}"/>
               </a:ext>
             </a:extLst>
           </p:cNvPr>
@@ -12430,7 +12430,7 @@
           <p:cNvPr id="2" name="">
             <a:extLst xmlns:a="http://schemas.openxmlformats.org/drawingml/2006/main">
               <a:ext uri="{FF2B5EF4-FFF2-40B4-BE49-F238E27FC236}">
-                <a16:creationId xmlns:a16="http://schemas.microsoft.com/office/drawing/2014/main" id="{8018F877-3C9E-46CE-AAB8-924482AD0346}"/>
+                <a16:creationId xmlns:a16="http://schemas.microsoft.com/office/drawing/2014/main" id="{472D6E4E-3F32-4571-A6DC-BE6A8FCDF070}"/>
               </a:ext>
             </a:extLst>
           </p:cNvPr>
@@ -12500,7 +12500,7 @@
           <p:cNvPr id="3" name="">
             <a:extLst xmlns:a="http://schemas.openxmlformats.org/drawingml/2006/main">
               <a:ext uri="{FF2B5EF4-FFF2-40B4-BE49-F238E27FC236}">
-                <a16:creationId xmlns:a16="http://schemas.microsoft.com/office/drawing/2014/main" id="{AAA30419-C8D7-4226-BB17-5DAAC31F06D8}"/>
+                <a16:creationId xmlns:a16="http://schemas.microsoft.com/office/drawing/2014/main" id="{A43AA36E-9BE7-4A19-9A92-E73E1E9FB476}"/>
               </a:ext>
             </a:extLst>
           </p:cNvPr>
@@ -12530,7 +12530,7 @@
           <p:cNvPr id="4" name="">
             <a:extLst xmlns:a="http://schemas.openxmlformats.org/drawingml/2006/main">
               <a:ext uri="{FF2B5EF4-FFF2-40B4-BE49-F238E27FC236}">
-                <a16:creationId xmlns:a16="http://schemas.microsoft.com/office/drawing/2014/main" id="{32C7C31D-D9BC-459A-8ED2-1C1ACC069193}"/>
+                <a16:creationId xmlns:a16="http://schemas.microsoft.com/office/drawing/2014/main" id="{F022904B-980E-4940-A2B0-8D8D8630106B}"/>
               </a:ext>
             </a:extLst>
           </p:cNvPr>
@@ -12600,7 +12600,7 @@
           <p:cNvPr id="5" name="">
             <a:extLst xmlns:a="http://schemas.openxmlformats.org/drawingml/2006/main">
               <a:ext uri="{FF2B5EF4-FFF2-40B4-BE49-F238E27FC236}">
-                <a16:creationId xmlns:a16="http://schemas.microsoft.com/office/drawing/2014/main" id="{B7B62748-C394-4819-99D7-FCCB85372BAD}"/>
+                <a16:creationId xmlns:a16="http://schemas.microsoft.com/office/drawing/2014/main" id="{C1B77E7E-0A80-4AB8-B649-7ECFE8844603}"/>
               </a:ext>
             </a:extLst>
           </p:cNvPr>
@@ -12670,7 +12670,7 @@
           <p:cNvPr id="6" name="">
             <a:extLst xmlns:a="http://schemas.openxmlformats.org/drawingml/2006/main">
               <a:ext uri="{FF2B5EF4-FFF2-40B4-BE49-F238E27FC236}">
-                <a16:creationId xmlns:a16="http://schemas.microsoft.com/office/drawing/2014/main" id="{BCD132AC-6970-4083-B8F4-B9C6F6909B48}"/>
+                <a16:creationId xmlns:a16="http://schemas.microsoft.com/office/drawing/2014/main" id="{3F86EA5F-05D6-4775-B64E-3AC1D24E3AD4}"/>
               </a:ext>
             </a:extLst>
           </p:cNvPr>
@@ -12740,7 +12740,7 @@
           <p:cNvPr id="7" name="">
             <a:extLst xmlns:a="http://schemas.openxmlformats.org/drawingml/2006/main">
               <a:ext uri="{FF2B5EF4-FFF2-40B4-BE49-F238E27FC236}">
-                <a16:creationId xmlns:a16="http://schemas.microsoft.com/office/drawing/2014/main" id="{001F11C0-908A-4CC4-AF67-3DC9A3777FA8}"/>
+                <a16:creationId xmlns:a16="http://schemas.microsoft.com/office/drawing/2014/main" id="{D88F3133-684E-4427-9653-B528C3F8F6DD}"/>
               </a:ext>
             </a:extLst>
           </p:cNvPr>
@@ -12810,7 +12810,7 @@
           <p:cNvPr id="8" name="">
             <a:extLst xmlns:a="http://schemas.openxmlformats.org/drawingml/2006/main">
               <a:ext uri="{FF2B5EF4-FFF2-40B4-BE49-F238E27FC236}">
-                <a16:creationId xmlns:a16="http://schemas.microsoft.com/office/drawing/2014/main" id="{8756C0A8-5BB8-4279-89F6-935B68505BAF}"/>
+                <a16:creationId xmlns:a16="http://schemas.microsoft.com/office/drawing/2014/main" id="{627B26FE-4D9B-41F5-838E-4CC48278F36C}"/>
               </a:ext>
             </a:extLst>
           </p:cNvPr>
@@ -12880,7 +12880,7 @@
           <p:cNvPr id="9" name="">
             <a:extLst xmlns:a="http://schemas.openxmlformats.org/drawingml/2006/main">
               <a:ext uri="{FF2B5EF4-FFF2-40B4-BE49-F238E27FC236}">
-                <a16:creationId xmlns:a16="http://schemas.microsoft.com/office/drawing/2014/main" id="{23A04F65-796D-46C9-BB63-B89497332E42}"/>
+                <a16:creationId xmlns:a16="http://schemas.microsoft.com/office/drawing/2014/main" id="{8201572D-A681-4CBD-946F-85C57B1E7EAD}"/>
               </a:ext>
             </a:extLst>
           </p:cNvPr>
@@ -12950,7 +12950,7 @@
           <p:cNvPr id="10" name="">
             <a:extLst xmlns:a="http://schemas.openxmlformats.org/drawingml/2006/main">
               <a:ext uri="{FF2B5EF4-FFF2-40B4-BE49-F238E27FC236}">
-                <a16:creationId xmlns:a16="http://schemas.microsoft.com/office/drawing/2014/main" id="{A98DF65E-801F-48EE-87A2-F79A75DEDE63}"/>
+                <a16:creationId xmlns:a16="http://schemas.microsoft.com/office/drawing/2014/main" id="{2CFF8BBA-E9D9-42D6-81C0-8F65A1E6FB10}"/>
               </a:ext>
             </a:extLst>
           </p:cNvPr>
@@ -13020,7 +13020,7 @@
           <p:cNvPr id="11" name="">
             <a:extLst xmlns:a="http://schemas.openxmlformats.org/drawingml/2006/main">
               <a:ext uri="{FF2B5EF4-FFF2-40B4-BE49-F238E27FC236}">
-                <a16:creationId xmlns:a16="http://schemas.microsoft.com/office/drawing/2014/main" id="{896A5DD6-E4A4-4871-B9E4-6958AEB69A28}"/>
+                <a16:creationId xmlns:a16="http://schemas.microsoft.com/office/drawing/2014/main" id="{6A9548E3-1C75-48FE-B577-6D052C0E75F4}"/>
               </a:ext>
             </a:extLst>
           </p:cNvPr>
@@ -13088,7 +13088,7 @@
     </p:spTree>
     <p:extLst>
       <p:ext uri="{BB962C8B-B14F-4D97-AF65-F5344CB8AC3E}">
-        <p14:creationId xmlns:p14="http://schemas.microsoft.com/office/powerpoint/2010/main" val="1209514466"/>
+        <p14:creationId xmlns:p14="http://schemas.microsoft.com/office/powerpoint/2010/main" val="731299295"/>
       </p:ext>
     </p:extLst>
   </p:cSld>
@@ -13119,7 +13119,7 @@
           <p:cNvPr id="15" name="">
             <a:extLst xmlns:a="http://schemas.openxmlformats.org/drawingml/2006/main">
               <a:ext uri="{FF2B5EF4-FFF2-40B4-BE49-F238E27FC236}">
-                <a16:creationId xmlns:a16="http://schemas.microsoft.com/office/drawing/2014/main" id="{09590312-E4C0-4F88-8371-ED9B6DCCC6FD}"/>
+                <a16:creationId xmlns:a16="http://schemas.microsoft.com/office/drawing/2014/main" id="{B85FE903-3C7C-4B63-828C-C68181BE9F6A}"/>
               </a:ext>
             </a:extLst>
           </p:cNvPr>
@@ -13189,7 +13189,7 @@
           <p:cNvPr id="2" name="">
             <a:extLst xmlns:a="http://schemas.openxmlformats.org/drawingml/2006/main">
               <a:ext uri="{FF2B5EF4-FFF2-40B4-BE49-F238E27FC236}">
-                <a16:creationId xmlns:a16="http://schemas.microsoft.com/office/drawing/2014/main" id="{346E475A-95A1-4C6E-8619-E72F7CCEB79D}"/>
+                <a16:creationId xmlns:a16="http://schemas.microsoft.com/office/drawing/2014/main" id="{8E565C94-5039-4B85-B9D0-0B421A2E33FB}"/>
               </a:ext>
             </a:extLst>
           </p:cNvPr>
@@ -13259,7 +13259,7 @@
           <p:cNvPr id="3" name="">
             <a:extLst xmlns:a="http://schemas.openxmlformats.org/drawingml/2006/main">
               <a:ext uri="{FF2B5EF4-FFF2-40B4-BE49-F238E27FC236}">
-                <a16:creationId xmlns:a16="http://schemas.microsoft.com/office/drawing/2014/main" id="{A21FBA75-62B9-40A3-91B4-2FE4F4158555}"/>
+                <a16:creationId xmlns:a16="http://schemas.microsoft.com/office/drawing/2014/main" id="{B989B5FB-FBBA-4DBB-99FB-BC608E99AA57}"/>
               </a:ext>
             </a:extLst>
           </p:cNvPr>
@@ -13289,7 +13289,7 @@
           <p:cNvPr id="4" name="">
             <a:extLst xmlns:a="http://schemas.openxmlformats.org/drawingml/2006/main">
               <a:ext uri="{FF2B5EF4-FFF2-40B4-BE49-F238E27FC236}">
-                <a16:creationId xmlns:a16="http://schemas.microsoft.com/office/drawing/2014/main" id="{A081A09E-0C13-4A7E-BE12-7E596CC9BD44}"/>
+                <a16:creationId xmlns:a16="http://schemas.microsoft.com/office/drawing/2014/main" id="{3958D76B-C1C8-4BF5-9169-9623C18594DF}"/>
               </a:ext>
             </a:extLst>
           </p:cNvPr>
@@ -13359,7 +13359,7 @@
           <p:cNvPr id="5" name="">
             <a:extLst xmlns:a="http://schemas.openxmlformats.org/drawingml/2006/main">
               <a:ext uri="{FF2B5EF4-FFF2-40B4-BE49-F238E27FC236}">
-                <a16:creationId xmlns:a16="http://schemas.microsoft.com/office/drawing/2014/main" id="{94E99530-409E-41F9-B29A-0690C548B188}"/>
+                <a16:creationId xmlns:a16="http://schemas.microsoft.com/office/drawing/2014/main" id="{D72222DB-EC72-4ACD-ADAB-BD5928827F4A}"/>
               </a:ext>
             </a:extLst>
           </p:cNvPr>
@@ -13429,7 +13429,7 @@
           <p:cNvPr id="6" name="">
             <a:extLst xmlns:a="http://schemas.openxmlformats.org/drawingml/2006/main">
               <a:ext uri="{FF2B5EF4-FFF2-40B4-BE49-F238E27FC236}">
-                <a16:creationId xmlns:a16="http://schemas.microsoft.com/office/drawing/2014/main" id="{42CC4980-01EA-44EB-BFEA-920BB29BC193}"/>
+                <a16:creationId xmlns:a16="http://schemas.microsoft.com/office/drawing/2014/main" id="{B2CC329E-8BF2-4AE7-81E0-957D42C1BF21}"/>
               </a:ext>
             </a:extLst>
           </p:cNvPr>
@@ -13499,7 +13499,7 @@
           <p:cNvPr id="7" name="">
             <a:extLst xmlns:a="http://schemas.openxmlformats.org/drawingml/2006/main">
               <a:ext uri="{FF2B5EF4-FFF2-40B4-BE49-F238E27FC236}">
-                <a16:creationId xmlns:a16="http://schemas.microsoft.com/office/drawing/2014/main" id="{A97A4A27-915A-4589-9D45-E817D66F3131}"/>
+                <a16:creationId xmlns:a16="http://schemas.microsoft.com/office/drawing/2014/main" id="{42F0C79B-A2F9-4B6F-91BB-5CF174BAC1FB}"/>
               </a:ext>
             </a:extLst>
           </p:cNvPr>
@@ -13569,7 +13569,7 @@
           <p:cNvPr id="8" name="">
             <a:extLst xmlns:a="http://schemas.openxmlformats.org/drawingml/2006/main">
               <a:ext uri="{FF2B5EF4-FFF2-40B4-BE49-F238E27FC236}">
-                <a16:creationId xmlns:a16="http://schemas.microsoft.com/office/drawing/2014/main" id="{8EE24B03-C016-4E26-A3E1-07F9ECE5AC89}"/>
+                <a16:creationId xmlns:a16="http://schemas.microsoft.com/office/drawing/2014/main" id="{542424D4-D750-410A-AF70-B18E60C70150}"/>
               </a:ext>
             </a:extLst>
           </p:cNvPr>
@@ -13666,7 +13666,7 @@
           <p:cNvPr id="9" name="">
             <a:extLst xmlns:a="http://schemas.openxmlformats.org/drawingml/2006/main">
               <a:ext uri="{FF2B5EF4-FFF2-40B4-BE49-F238E27FC236}">
-                <a16:creationId xmlns:a16="http://schemas.microsoft.com/office/drawing/2014/main" id="{B719C8A2-21B1-407E-BA8C-A35B3D416344}"/>
+                <a16:creationId xmlns:a16="http://schemas.microsoft.com/office/drawing/2014/main" id="{9FDA1B61-5A6E-4D6B-8380-D975CFCAA644}"/>
               </a:ext>
             </a:extLst>
           </p:cNvPr>
@@ -13736,7 +13736,7 @@
           <p:cNvPr id="10" name="">
             <a:extLst xmlns:a="http://schemas.openxmlformats.org/drawingml/2006/main">
               <a:ext uri="{FF2B5EF4-FFF2-40B4-BE49-F238E27FC236}">
-                <a16:creationId xmlns:a16="http://schemas.microsoft.com/office/drawing/2014/main" id="{C1136931-C505-4019-A091-2C3F1D4B0539}"/>
+                <a16:creationId xmlns:a16="http://schemas.microsoft.com/office/drawing/2014/main" id="{8C917C84-64F6-4C04-891B-6285EAC391A0}"/>
               </a:ext>
             </a:extLst>
           </p:cNvPr>
@@ -13806,7 +13806,7 @@
           <p:cNvPr id="11" name="">
             <a:extLst xmlns:a="http://schemas.openxmlformats.org/drawingml/2006/main">
               <a:ext uri="{FF2B5EF4-FFF2-40B4-BE49-F238E27FC236}">
-                <a16:creationId xmlns:a16="http://schemas.microsoft.com/office/drawing/2014/main" id="{108258FC-B0D9-43E2-8EC7-1A27678A255D}"/>
+                <a16:creationId xmlns:a16="http://schemas.microsoft.com/office/drawing/2014/main" id="{818D591B-B6EF-4721-A7B4-945533049170}"/>
               </a:ext>
             </a:extLst>
           </p:cNvPr>
@@ -13903,7 +13903,7 @@
           <p:cNvPr id="12" name="">
             <a:extLst xmlns:a="http://schemas.openxmlformats.org/drawingml/2006/main">
               <a:ext uri="{FF2B5EF4-FFF2-40B4-BE49-F238E27FC236}">
-                <a16:creationId xmlns:a16="http://schemas.microsoft.com/office/drawing/2014/main" id="{6345CB1C-186E-42FB-9009-03F17B6C98F7}"/>
+                <a16:creationId xmlns:a16="http://schemas.microsoft.com/office/drawing/2014/main" id="{89AD00F1-3F56-4171-8857-8D81B8D45F30}"/>
               </a:ext>
             </a:extLst>
           </p:cNvPr>
@@ -13973,7 +13973,7 @@
           <p:cNvPr id="13" name="">
             <a:extLst xmlns:a="http://schemas.openxmlformats.org/drawingml/2006/main">
               <a:ext uri="{FF2B5EF4-FFF2-40B4-BE49-F238E27FC236}">
-                <a16:creationId xmlns:a16="http://schemas.microsoft.com/office/drawing/2014/main" id="{5C77AA71-CD13-4BA3-A2D5-AF1155EE2F1B}"/>
+                <a16:creationId xmlns:a16="http://schemas.microsoft.com/office/drawing/2014/main" id="{692510D6-D067-4526-BC15-D0A50876234B}"/>
               </a:ext>
             </a:extLst>
           </p:cNvPr>
@@ -14043,7 +14043,7 @@
           <p:cNvPr id="14" name="">
             <a:extLst xmlns:a="http://schemas.openxmlformats.org/drawingml/2006/main">
               <a:ext uri="{FF2B5EF4-FFF2-40B4-BE49-F238E27FC236}">
-                <a16:creationId xmlns:a16="http://schemas.microsoft.com/office/drawing/2014/main" id="{9464DC6A-0629-4CEF-8EF1-A3C6E427E4E2}"/>
+                <a16:creationId xmlns:a16="http://schemas.microsoft.com/office/drawing/2014/main" id="{305BDF6B-18D0-4B9E-836E-333D0E7E01C1}"/>
               </a:ext>
             </a:extLst>
           </p:cNvPr>
@@ -14138,7 +14138,7 @@
     </p:spTree>
     <p:extLst>
       <p:ext uri="{BB962C8B-B14F-4D97-AF65-F5344CB8AC3E}">
-        <p14:creationId xmlns:p14="http://schemas.microsoft.com/office/powerpoint/2010/main" val="126947716"/>
+        <p14:creationId xmlns:p14="http://schemas.microsoft.com/office/powerpoint/2010/main" val="1927597813"/>
       </p:ext>
     </p:extLst>
   </p:cSld>
@@ -14169,7 +14169,7 @@
           <p:cNvPr id="15" name="">
             <a:extLst xmlns:a="http://schemas.openxmlformats.org/drawingml/2006/main">
               <a:ext uri="{FF2B5EF4-FFF2-40B4-BE49-F238E27FC236}">
-                <a16:creationId xmlns:a16="http://schemas.microsoft.com/office/drawing/2014/main" id="{FFF359E3-3A50-4310-82B6-E4436BEC9C97}"/>
+                <a16:creationId xmlns:a16="http://schemas.microsoft.com/office/drawing/2014/main" id="{C8B6923D-77BA-4A13-A3AA-493386EB0995}"/>
               </a:ext>
             </a:extLst>
           </p:cNvPr>
@@ -14239,7 +14239,7 @@
           <p:cNvPr id="2" name="">
             <a:extLst xmlns:a="http://schemas.openxmlformats.org/drawingml/2006/main">
               <a:ext uri="{FF2B5EF4-FFF2-40B4-BE49-F238E27FC236}">
-                <a16:creationId xmlns:a16="http://schemas.microsoft.com/office/drawing/2014/main" id="{5F3B7D18-331C-4729-AE4C-6B37965F4068}"/>
+                <a16:creationId xmlns:a16="http://schemas.microsoft.com/office/drawing/2014/main" id="{3F5A1D44-32AC-4E60-8D1E-C6A9A8AAB297}"/>
               </a:ext>
             </a:extLst>
           </p:cNvPr>
@@ -14309,7 +14309,7 @@
           <p:cNvPr id="3" name="">
             <a:extLst xmlns:a="http://schemas.openxmlformats.org/drawingml/2006/main">
               <a:ext uri="{FF2B5EF4-FFF2-40B4-BE49-F238E27FC236}">
-                <a16:creationId xmlns:a16="http://schemas.microsoft.com/office/drawing/2014/main" id="{1F90FC59-ECEA-452B-9818-574C90D5D62E}"/>
+                <a16:creationId xmlns:a16="http://schemas.microsoft.com/office/drawing/2014/main" id="{0444DAA8-1D01-48D9-B654-A9D05746E50F}"/>
               </a:ext>
             </a:extLst>
           </p:cNvPr>
@@ -14339,7 +14339,7 @@
           <p:cNvPr id="4" name="">
             <a:extLst xmlns:a="http://schemas.openxmlformats.org/drawingml/2006/main">
               <a:ext uri="{FF2B5EF4-FFF2-40B4-BE49-F238E27FC236}">
-                <a16:creationId xmlns:a16="http://schemas.microsoft.com/office/drawing/2014/main" id="{D2B18839-DEDE-40B0-8888-6CC0DE49EDE6}"/>
+                <a16:creationId xmlns:a16="http://schemas.microsoft.com/office/drawing/2014/main" id="{DAEBFC6F-1CA3-4C8E-867C-042FA85BECF5}"/>
               </a:ext>
             </a:extLst>
           </p:cNvPr>
@@ -14409,7 +14409,7 @@
           <p:cNvPr id="5" name="">
             <a:extLst xmlns:a="http://schemas.openxmlformats.org/drawingml/2006/main">
               <a:ext uri="{FF2B5EF4-FFF2-40B4-BE49-F238E27FC236}">
-                <a16:creationId xmlns:a16="http://schemas.microsoft.com/office/drawing/2014/main" id="{42EF7823-9033-4E19-B454-F1CA8CF35CCF}"/>
+                <a16:creationId xmlns:a16="http://schemas.microsoft.com/office/drawing/2014/main" id="{C24AB614-152A-4938-B3C4-521C12E0E418}"/>
               </a:ext>
             </a:extLst>
           </p:cNvPr>
@@ -14479,7 +14479,7 @@
           <p:cNvPr id="6" name="">
             <a:extLst xmlns:a="http://schemas.openxmlformats.org/drawingml/2006/main">
               <a:ext uri="{FF2B5EF4-FFF2-40B4-BE49-F238E27FC236}">
-                <a16:creationId xmlns:a16="http://schemas.microsoft.com/office/drawing/2014/main" id="{4FDE6B48-1F48-4CAC-983D-AE7473C99576}"/>
+                <a16:creationId xmlns:a16="http://schemas.microsoft.com/office/drawing/2014/main" id="{023DF3FC-D77B-463D-8801-D09B09EB0511}"/>
               </a:ext>
             </a:extLst>
           </p:cNvPr>
@@ -14489,7 +14489,7 @@
           <p:nvPr/>
         </p:nvPicPr>
         <p:blipFill>
-          <a:blip xmlns:r="http://schemas.openxmlformats.org/officeDocument/2006/relationships" xmlns:a="http://schemas.openxmlformats.org/drawingml/2006/main" r:embed="R80e02309b55a446f"/>
+          <a:blip xmlns:r="http://schemas.openxmlformats.org/officeDocument/2006/relationships" xmlns:a="http://schemas.openxmlformats.org/drawingml/2006/main" r:embed="R81706c65b2dc4f3d"/>
           <a:stretch xmlns:a="http://schemas.openxmlformats.org/drawingml/2006/main"/>
         </p:blipFill>
         <p:spPr>
@@ -14507,7 +14507,7 @@
           <p:cNvPr id="7" name="">
             <a:extLst xmlns:a="http://schemas.openxmlformats.org/drawingml/2006/main">
               <a:ext uri="{FF2B5EF4-FFF2-40B4-BE49-F238E27FC236}">
-                <a16:creationId xmlns:a16="http://schemas.microsoft.com/office/drawing/2014/main" id="{A2C3E9AE-362B-4D7D-9402-BBCEBB957D5B}"/>
+                <a16:creationId xmlns:a16="http://schemas.microsoft.com/office/drawing/2014/main" id="{1D6DC102-400B-4395-8D5F-4D3936F11B91}"/>
               </a:ext>
             </a:extLst>
           </p:cNvPr>
@@ -14577,7 +14577,7 @@
           <p:cNvPr id="8" name="">
             <a:extLst xmlns:a="http://schemas.openxmlformats.org/drawingml/2006/main">
               <a:ext uri="{FF2B5EF4-FFF2-40B4-BE49-F238E27FC236}">
-                <a16:creationId xmlns:a16="http://schemas.microsoft.com/office/drawing/2014/main" id="{5479B59B-9BCC-4D9E-8ED8-35B4480A4185}"/>
+                <a16:creationId xmlns:a16="http://schemas.microsoft.com/office/drawing/2014/main" id="{183ADC9C-86BA-4C88-A648-9169A727CF31}"/>
               </a:ext>
             </a:extLst>
           </p:cNvPr>
@@ -14647,7 +14647,7 @@
           <p:cNvPr id="9" name="">
             <a:extLst xmlns:a="http://schemas.openxmlformats.org/drawingml/2006/main">
               <a:ext uri="{FF2B5EF4-FFF2-40B4-BE49-F238E27FC236}">
-                <a16:creationId xmlns:a16="http://schemas.microsoft.com/office/drawing/2014/main" id="{67F72394-D651-4027-873B-6C08C1EBFBF6}"/>
+                <a16:creationId xmlns:a16="http://schemas.microsoft.com/office/drawing/2014/main" id="{129D0B08-CA5D-4C3F-B5F9-1852A6F9BB97}"/>
               </a:ext>
             </a:extLst>
           </p:cNvPr>
@@ -14657,7 +14657,7 @@
           <p:nvPr/>
         </p:nvPicPr>
         <p:blipFill>
-          <a:blip xmlns:r="http://schemas.openxmlformats.org/officeDocument/2006/relationships" xmlns:a="http://schemas.openxmlformats.org/drawingml/2006/main" r:embed="R64672d9acd814515"/>
+          <a:blip xmlns:r="http://schemas.openxmlformats.org/officeDocument/2006/relationships" xmlns:a="http://schemas.openxmlformats.org/drawingml/2006/main" r:embed="Re787fd1c6a964ffc"/>
           <a:stretch xmlns:a="http://schemas.openxmlformats.org/drawingml/2006/main"/>
         </p:blipFill>
         <p:spPr>
@@ -14675,7 +14675,7 @@
           <p:cNvPr id="10" name="">
             <a:extLst xmlns:a="http://schemas.openxmlformats.org/drawingml/2006/main">
               <a:ext uri="{FF2B5EF4-FFF2-40B4-BE49-F238E27FC236}">
-                <a16:creationId xmlns:a16="http://schemas.microsoft.com/office/drawing/2014/main" id="{78268A43-9A50-4A5B-BDA2-1739A92BD41B}"/>
+                <a16:creationId xmlns:a16="http://schemas.microsoft.com/office/drawing/2014/main" id="{8C9C8504-5142-410E-8D55-26C234981A98}"/>
               </a:ext>
             </a:extLst>
           </p:cNvPr>
@@ -14745,7 +14745,7 @@
           <p:cNvPr id="11" name="">
             <a:extLst xmlns:a="http://schemas.openxmlformats.org/drawingml/2006/main">
               <a:ext uri="{FF2B5EF4-FFF2-40B4-BE49-F238E27FC236}">
-                <a16:creationId xmlns:a16="http://schemas.microsoft.com/office/drawing/2014/main" id="{FD798405-7CAA-4FD0-A6BB-9AB7FF72581D}"/>
+                <a16:creationId xmlns:a16="http://schemas.microsoft.com/office/drawing/2014/main" id="{82B4D69F-EC23-43B8-B654-022DBB68A1AE}"/>
               </a:ext>
             </a:extLst>
           </p:cNvPr>
@@ -14815,7 +14815,7 @@
           <p:cNvPr id="12" name="">
             <a:extLst xmlns:a="http://schemas.openxmlformats.org/drawingml/2006/main">
               <a:ext uri="{FF2B5EF4-FFF2-40B4-BE49-F238E27FC236}">
-                <a16:creationId xmlns:a16="http://schemas.microsoft.com/office/drawing/2014/main" id="{BBACD2FE-C1C6-4400-9B8A-203A04E88D8C}"/>
+                <a16:creationId xmlns:a16="http://schemas.microsoft.com/office/drawing/2014/main" id="{7026C60B-E324-4988-85C0-9B63697C8930}"/>
               </a:ext>
             </a:extLst>
           </p:cNvPr>
@@ -14825,7 +14825,7 @@
           <p:nvPr/>
         </p:nvPicPr>
         <p:blipFill>
-          <a:blip xmlns:r="http://schemas.openxmlformats.org/officeDocument/2006/relationships" xmlns:a="http://schemas.openxmlformats.org/drawingml/2006/main" r:embed="R9d73dbc84fab425a"/>
+          <a:blip xmlns:r="http://schemas.openxmlformats.org/officeDocument/2006/relationships" xmlns:a="http://schemas.openxmlformats.org/drawingml/2006/main" r:embed="Rdc6ec5999f454c9f"/>
           <a:stretch xmlns:a="http://schemas.openxmlformats.org/drawingml/2006/main"/>
         </p:blipFill>
         <p:spPr>
@@ -14843,7 +14843,7 @@
           <p:cNvPr id="13" name="">
             <a:extLst xmlns:a="http://schemas.openxmlformats.org/drawingml/2006/main">
               <a:ext uri="{FF2B5EF4-FFF2-40B4-BE49-F238E27FC236}">
-                <a16:creationId xmlns:a16="http://schemas.microsoft.com/office/drawing/2014/main" id="{1D8A174D-FF6D-42CF-BE2C-F1975578CC8D}"/>
+                <a16:creationId xmlns:a16="http://schemas.microsoft.com/office/drawing/2014/main" id="{5F020B9C-8E73-469B-85E5-53B6CA54C3CD}"/>
               </a:ext>
             </a:extLst>
           </p:cNvPr>
@@ -14913,7 +14913,7 @@
           <p:cNvPr id="14" name="">
             <a:extLst xmlns:a="http://schemas.openxmlformats.org/drawingml/2006/main">
               <a:ext uri="{FF2B5EF4-FFF2-40B4-BE49-F238E27FC236}">
-                <a16:creationId xmlns:a16="http://schemas.microsoft.com/office/drawing/2014/main" id="{96DC85FE-D7B9-4783-A9C6-6779E4B11D5B}"/>
+                <a16:creationId xmlns:a16="http://schemas.microsoft.com/office/drawing/2014/main" id="{9BFD7B78-FAD5-4779-945F-4EC5E875CD3C}"/>
               </a:ext>
             </a:extLst>
           </p:cNvPr>
@@ -14981,7 +14981,7 @@
     </p:spTree>
     <p:extLst>
       <p:ext uri="{BB962C8B-B14F-4D97-AF65-F5344CB8AC3E}">
-        <p14:creationId xmlns:p14="http://schemas.microsoft.com/office/powerpoint/2010/main" val="1983670130"/>
+        <p14:creationId xmlns:p14="http://schemas.microsoft.com/office/powerpoint/2010/main" val="1151542331"/>
       </p:ext>
     </p:extLst>
   </p:cSld>

</xml_diff>